<commit_message>
Redesign the technical presentation and the architecture document
Technical presentation (5 slides), now in the same clean style as the idea deck:
- Overview with the dashboard and four headline results
- Architecture diagram with the flow, packet and ingestion details
- World model explained next to real dashboard output: the 60 s forecast,
  Integrated Gradients and host attribution at a DDoS onset
- Results chart (forecast, early warning, detection vs the baseline) with
  where we lead, where the baseline leads, and the open problem
- Demo, deployment, limits, next steps, reproduction, QR codes for the video
  and the repository

Architecture document (2 pages): title block with the logo, key-figures strip,
components table, restyled results table with plain findings, the prototype
screenshot instead of the dense timeline plot, links and page numbers.
Document properties name the team.
</commit_message>
<xml_diff>
--- a/docs/VIGHNAX_Technical_Presentation.pptx
+++ b/docs/VIGHNAX_Technical_Presentation.pptx
@@ -3085,14 +3085,6 @@
 <file path=ppt/slides/slide1.xml><?xml version="1.0" encoding="utf-8"?>
 <p:sld xmlns:a="http://schemas.openxmlformats.org/drawingml/2006/main" xmlns:p="http://schemas.openxmlformats.org/presentationml/2006/main" xmlns:r="http://schemas.openxmlformats.org/officeDocument/2006/relationships">
   <p:cSld>
-    <p:bg>
-      <p:bgPr>
-        <a:solidFill>
-          <a:srgbClr val="0E1116"/>
-        </a:solidFill>
-        <a:effectLst/>
-      </p:bgPr>
-    </p:bg>
     <p:spTree>
       <p:nvGrpSpPr>
         <p:cNvPr id="1" name=""/>
@@ -3100,16 +3092,40 @@
         <p:nvPr/>
       </p:nvGrpSpPr>
       <p:grpSpPr/>
-      <p:sp>
-        <p:nvSpPr>
-          <p:cNvPr id="2" name="TextBox 1"/>
+      <p:pic>
+        <p:nvPicPr>
+          <p:cNvPr id="2" name="Picture 1" descr="logo_brown.png"/>
+          <p:cNvPicPr>
+            <a:picLocks noChangeAspect="1"/>
+          </p:cNvPicPr>
+          <p:nvPr/>
+        </p:nvPicPr>
+        <p:blipFill>
+          <a:blip r:embed="rId2"/>
+          <a:stretch>
+            <a:fillRect/>
+          </a:stretch>
+        </p:blipFill>
+        <p:spPr>
+          <a:xfrm>
+            <a:off x="457200" y="329184"/>
+            <a:ext cx="537496" cy="603504"/>
+          </a:xfrm>
+          <a:prstGeom prst="rect">
+            <a:avLst/>
+          </a:prstGeom>
+        </p:spPr>
+      </p:pic>
+      <p:sp>
+        <p:nvSpPr>
+          <p:cNvPr id="3" name="TextBox 2"/>
           <p:cNvSpPr txBox="1"/>
           <p:nvPr/>
         </p:nvSpPr>
         <p:spPr>
           <a:xfrm>
-            <a:off x="548640" y="320040"/>
-            <a:ext cx="11064240" cy="822960"/>
+            <a:off x="1097280" y="237744"/>
+            <a:ext cx="10698480" cy="960120"/>
           </a:xfrm>
           <a:prstGeom prst="rect">
             <a:avLst/>
@@ -3117,42 +3133,97 @@
           <a:noFill/>
         </p:spPr>
         <p:txBody>
-          <a:bodyPr wrap="none">
+          <a:bodyPr wrap="square">
             <a:spAutoFit/>
           </a:bodyPr>
           <a:lstStyle/>
           <a:p>
-            <a:r>
-              <a:rPr sz="3000" b="1">
-                <a:solidFill>
-                  <a:srgbClr val="E6EDF3"/>
-                </a:solidFill>
-              </a:rPr>
-              <a:t>VIGHNAX — forecasting attacks before they complete</a:t>
-            </a:r>
-          </a:p>
-          <a:p>
-            <a:r>
-              <a:rPr sz="1400">
-                <a:solidFill>
-                  <a:srgbClr val="2DD4BF"/>
-                </a:solidFill>
-              </a:rPr>
-              <a:t>SIH 2026 · SIH26153 (NTRO) · AI-based Network Attack Forecasting from Network Traffic Data · Team VIGHNAX (127364)</a:t>
-            </a:r>
-          </a:p>
-        </p:txBody>
-      </p:sp>
-      <p:sp>
-        <p:nvSpPr>
-          <p:cNvPr id="3" name="TextBox 2"/>
+            <a:pPr marL="0" indent="0">
+              <a:buNone/>
+            </a:pPr>
+            <a:r>
+              <a:rPr sz="2800" b="1">
+                <a:solidFill>
+                  <a:srgbClr val="202020"/>
+                </a:solidFill>
+                <a:latin typeface="Arial"/>
+              </a:rPr>
+              <a:t>Forecasting network attacks before they complete</a:t>
+            </a:r>
+          </a:p>
+          <a:p>
+            <a:pPr marL="0" indent="0">
+              <a:spcBef>
+                <a:spcPts val="200"/>
+              </a:spcBef>
+              <a:buNone/>
+            </a:pPr>
+            <a:r>
+              <a:rPr sz="1350" b="0">
+                <a:solidFill>
+                  <a:srgbClr val="1F4E9A"/>
+                </a:solidFill>
+                <a:latin typeface="Arial"/>
+              </a:rPr>
+              <a:t>VIGHNAX · a world model for SIH26153 (NTRO): AI-based Network Attack Forecasting from Network Traffic Data</a:t>
+            </a:r>
+          </a:p>
+        </p:txBody>
+      </p:sp>
+      <p:sp>
+        <p:nvSpPr>
+          <p:cNvPr id="4" name="Rectangle 3"/>
+          <p:cNvSpPr/>
+          <p:nvPr/>
+        </p:nvSpPr>
+        <p:spPr>
+          <a:xfrm>
+            <a:off x="457200" y="6391656"/>
+            <a:ext cx="11274552" cy="10972"/>
+          </a:xfrm>
+          <a:prstGeom prst="rect">
+            <a:avLst/>
+          </a:prstGeom>
+          <a:solidFill>
+            <a:srgbClr val="C9D3E3"/>
+          </a:solidFill>
+          <a:ln>
+            <a:noFill/>
+          </a:ln>
+          <a:effectLst/>
+        </p:spPr>
+        <p:style>
+          <a:lnRef idx="1">
+            <a:schemeClr val="accent1"/>
+          </a:lnRef>
+          <a:fillRef idx="3">
+            <a:schemeClr val="accent1"/>
+          </a:fillRef>
+          <a:effectRef idx="2">
+            <a:schemeClr val="accent1"/>
+          </a:effectRef>
+          <a:fontRef idx="minor">
+            <a:schemeClr val="lt1"/>
+          </a:fontRef>
+        </p:style>
+        <p:txBody>
+          <a:bodyPr rtlCol="0" anchor="ctr"/>
+          <a:lstStyle/>
+          <a:p>
+            <a:pPr algn="ctr"/>
+          </a:p>
+        </p:txBody>
+      </p:sp>
+      <p:sp>
+        <p:nvSpPr>
+          <p:cNvPr id="5" name="TextBox 4"/>
           <p:cNvSpPr txBox="1"/>
           <p:nvPr/>
         </p:nvSpPr>
         <p:spPr>
           <a:xfrm>
-            <a:off x="548640" y="1554480"/>
-            <a:ext cx="11064240" cy="4846320"/>
+            <a:off x="457200" y="6419088"/>
+            <a:ext cx="9144000" cy="274320"/>
           </a:xfrm>
           <a:prstGeom prst="rect">
             <a:avLst/>
@@ -3165,118 +3236,538 @@
           </a:bodyPr>
           <a:lstStyle/>
           <a:p>
-            <a:pPr>
-              <a:spcAft>
-                <a:spcPts val="800"/>
-              </a:spcAft>
-            </a:pPr>
-            <a:r>
-              <a:rPr b="1" sz="1900">
-                <a:solidFill>
-                  <a:srgbClr val="2DD4BF"/>
-                </a:solidFill>
-              </a:rPr>
-              <a:t>Problem:</a:t>
-            </a:r>
-            <a:r>
-              <a:rPr sz="1900">
-                <a:solidFill>
-                  <a:srgbClr val="E6EDF3"/>
-                </a:solidFill>
-              </a:rPr>
-              <a:t> IDS models label each flow in isolation and fire after the fact; an infiltration is a process unfolding over time.</a:t>
-            </a:r>
-          </a:p>
-          <a:p>
-            <a:pPr>
-              <a:spcAft>
-                <a:spcPts val="800"/>
-              </a:spcAft>
-            </a:pPr>
-            <a:r>
-              <a:rPr b="1" sz="1900">
-                <a:solidFill>
-                  <a:srgbClr val="2DD4BF"/>
-                </a:solidFill>
-              </a:rPr>
-              <a:t>Idea:</a:t>
-            </a:r>
-            <a:r>
-              <a:rPr sz="1900">
-                <a:solidFill>
-                  <a:srgbClr val="E6EDF3"/>
-                </a:solidFill>
-              </a:rPr>
-              <a:t> learn a world model of network state dynamics P(S_t+1 | S_≤t) from flow + packet telemetry, and simulate K steps ahead.</a:t>
-            </a:r>
-          </a:p>
-          <a:p>
-            <a:pPr>
-              <a:spcAft>
-                <a:spcPts val="800"/>
-              </a:spcAft>
-            </a:pPr>
-            <a:r>
-              <a:rPr b="1" sz="1900">
-                <a:solidFill>
-                  <a:srgbClr val="2DD4BF"/>
-                </a:solidFill>
-              </a:rPr>
-              <a:t>Output:</a:t>
-            </a:r>
-            <a:r>
-              <a:rPr sz="1900">
-                <a:solidFill>
-                  <a:srgbClr val="E6EDF3"/>
-                </a:solidFill>
-              </a:rPr>
-              <a:t> P(infiltration in next 60 s) with an uncertainty band, predicted MITRE ATT&amp;CK stage, driving features, flagged hosts/flows.</a:t>
-            </a:r>
-          </a:p>
-          <a:p>
-            <a:pPr>
-              <a:spcAft>
-                <a:spcPts val="800"/>
-              </a:spcAft>
-            </a:pPr>
-            <a:r>
-              <a:rPr b="1" sz="1900">
-                <a:solidFill>
-                  <a:srgbClr val="2DD4BF"/>
-                </a:solidFill>
-              </a:rPr>
-              <a:t>Evidence:</a:t>
-            </a:r>
-            <a:r>
-              <a:rPr sz="1900">
-                <a:solidFill>
-                  <a:srgbClr val="E6EDF3"/>
-                </a:solidFill>
-              </a:rPr>
-              <a:t> one model, all 7 PS datasets, unseen test data: forecast macro AUROC 0.70 vs 0.67 (LR); 54/201 attack onsets forecast before they began (LR 17).</a:t>
-            </a:r>
-          </a:p>
-          <a:p>
-            <a:pPr>
-              <a:spcAft>
-                <a:spcPts val="800"/>
-              </a:spcAft>
-            </a:pPr>
-            <a:r>
-              <a:rPr b="1" sz="1900">
-                <a:solidFill>
-                  <a:srgbClr val="2DD4BF"/>
-                </a:solidFill>
-              </a:rPr>
-              <a:t>Practical:</a:t>
-            </a:r>
-            <a:r>
-              <a:rPr sz="1900">
-                <a:solidFill>
-                  <a:srgbClr val="E6EDF3"/>
-                </a:solidFill>
-              </a:rPr>
-              <a:t> open source (MIT), fully offline: ~8 ms per 10 s window on a laptop CPU, 0.04 ms batched on GPU; ~125k packets/s ingestion.</a:t>
+            <a:pPr marL="0" indent="0">
+              <a:buNone/>
+            </a:pPr>
+            <a:r>
+              <a:rPr sz="900" b="0">
+                <a:solidFill>
+                  <a:srgbClr val="555555"/>
+                </a:solidFill>
+                <a:latin typeface="Arial"/>
+              </a:rPr>
+              <a:t>VIGHNAX · SIH 2026 · PS SIH26153 (NTRO) · Team ID 127364</a:t>
+            </a:r>
+          </a:p>
+        </p:txBody>
+      </p:sp>
+      <p:sp>
+        <p:nvSpPr>
+          <p:cNvPr id="6" name="TextBox 5"/>
+          <p:cNvSpPr txBox="1"/>
+          <p:nvPr/>
+        </p:nvSpPr>
+        <p:spPr>
+          <a:xfrm>
+            <a:off x="10789920" y="6419088"/>
+            <a:ext cx="941832" cy="274320"/>
+          </a:xfrm>
+          <a:prstGeom prst="rect">
+            <a:avLst/>
+          </a:prstGeom>
+          <a:noFill/>
+        </p:spPr>
+        <p:txBody>
+          <a:bodyPr wrap="square">
+            <a:spAutoFit/>
+          </a:bodyPr>
+          <a:lstStyle/>
+          <a:p>
+            <a:pPr marL="0" indent="0" algn="r">
+              <a:buNone/>
+            </a:pPr>
+            <a:r>
+              <a:rPr sz="900" b="0">
+                <a:solidFill>
+                  <a:srgbClr val="555555"/>
+                </a:solidFill>
+                <a:latin typeface="Arial"/>
+              </a:rPr>
+              <a:t>1 / 5</a:t>
+            </a:r>
+          </a:p>
+        </p:txBody>
+      </p:sp>
+      <p:sp>
+        <p:nvSpPr>
+          <p:cNvPr id="7" name="TextBox 6"/>
+          <p:cNvSpPr txBox="1"/>
+          <p:nvPr/>
+        </p:nvSpPr>
+        <p:spPr>
+          <a:xfrm>
+            <a:off x="457200" y="1417320"/>
+            <a:ext cx="5669280" cy="3383280"/>
+          </a:xfrm>
+          <a:prstGeom prst="rect">
+            <a:avLst/>
+          </a:prstGeom>
+          <a:noFill/>
+        </p:spPr>
+        <p:txBody>
+          <a:bodyPr wrap="square">
+            <a:spAutoFit/>
+          </a:bodyPr>
+          <a:lstStyle/>
+          <a:p>
+            <a:pPr marL="0" indent="0">
+              <a:buNone/>
+            </a:pPr>
+            <a:r>
+              <a:rPr sz="1250" b="1">
+                <a:solidFill>
+                  <a:srgbClr val="1F4E9A"/>
+                </a:solidFill>
+                <a:latin typeface="Arial"/>
+              </a:rPr>
+              <a:t>PROBLEM</a:t>
+            </a:r>
+          </a:p>
+          <a:p>
+            <a:pPr marL="0" indent="0">
+              <a:spcBef>
+                <a:spcPts val="100"/>
+              </a:spcBef>
+              <a:buNone/>
+            </a:pPr>
+            <a:r>
+              <a:rPr sz="1500" b="0">
+                <a:solidFill>
+                  <a:srgbClr val="202020"/>
+                </a:solidFill>
+                <a:latin typeface="Arial"/>
+              </a:rPr>
+              <a:t>Intrusion detection labels each flow in isolation and fires after the fact, but an infiltration is a process that unfolds over time.</a:t>
+            </a:r>
+          </a:p>
+          <a:p>
+            <a:pPr marL="0" indent="0">
+              <a:spcBef>
+                <a:spcPts val="900"/>
+              </a:spcBef>
+              <a:buNone/>
+            </a:pPr>
+            <a:r>
+              <a:rPr sz="1250" b="1">
+                <a:solidFill>
+                  <a:srgbClr val="1F4E9A"/>
+                </a:solidFill>
+                <a:latin typeface="Arial"/>
+              </a:rPr>
+              <a:t>IDEA</a:t>
+            </a:r>
+          </a:p>
+          <a:p>
+            <a:pPr marL="0" indent="0">
+              <a:spcBef>
+                <a:spcPts val="100"/>
+              </a:spcBef>
+              <a:buNone/>
+            </a:pPr>
+            <a:r>
+              <a:rPr sz="1500" b="0">
+                <a:solidFill>
+                  <a:srgbClr val="202020"/>
+                </a:solidFill>
+                <a:latin typeface="Arial"/>
+              </a:rPr>
+              <a:t>Learn a world model of how the network's state evolves, P(S_t+1 | S_≤t), from flow and packet telemetry, then simulate it 60 s into the future.</a:t>
+            </a:r>
+          </a:p>
+          <a:p>
+            <a:pPr marL="0" indent="0">
+              <a:spcBef>
+                <a:spcPts val="900"/>
+              </a:spcBef>
+              <a:buNone/>
+            </a:pPr>
+            <a:r>
+              <a:rPr sz="1250" b="1">
+                <a:solidFill>
+                  <a:srgbClr val="1F4E9A"/>
+                </a:solidFill>
+                <a:latin typeface="Arial"/>
+              </a:rPr>
+              <a:t>OUTPUT, EVERY 10 S</a:t>
+            </a:r>
+          </a:p>
+          <a:p>
+            <a:pPr marL="0" indent="0">
+              <a:spcBef>
+                <a:spcPts val="100"/>
+              </a:spcBef>
+              <a:buNone/>
+            </a:pPr>
+            <a:r>
+              <a:rPr sz="1500" b="0">
+                <a:solidFill>
+                  <a:srgbClr val="202020"/>
+                </a:solidFill>
+                <a:latin typeface="Arial"/>
+              </a:rPr>
+              <a:t>P(attack within 60 s) with an uncertainty band, the next MITRE ATT&amp;CK stage, and the features and hosts behind it.</a:t>
+            </a:r>
+          </a:p>
+        </p:txBody>
+      </p:sp>
+      <p:pic>
+        <p:nvPicPr>
+          <p:cNvPr id="8" name="Picture 7" descr="dashboard_light.png"/>
+          <p:cNvPicPr>
+            <a:picLocks noChangeAspect="1"/>
+          </p:cNvPicPr>
+          <p:nvPr/>
+        </p:nvPicPr>
+        <p:blipFill>
+          <a:blip r:embed="rId3"/>
+          <a:stretch>
+            <a:fillRect/>
+          </a:stretch>
+        </p:blipFill>
+        <p:spPr>
+          <a:xfrm>
+            <a:off x="6355080" y="1463040"/>
+            <a:ext cx="5376672" cy="2897429"/>
+          </a:xfrm>
+          <a:prstGeom prst="rect">
+            <a:avLst/>
+          </a:prstGeom>
+          <a:ln w="9525">
+            <a:solidFill>
+              <a:srgbClr val="C9D3E3"/>
+            </a:solidFill>
+          </a:ln>
+        </p:spPr>
+      </p:pic>
+      <p:sp>
+        <p:nvSpPr>
+          <p:cNvPr id="9" name="TextBox 8"/>
+          <p:cNvSpPr txBox="1"/>
+          <p:nvPr/>
+        </p:nvSpPr>
+        <p:spPr>
+          <a:xfrm>
+            <a:off x="6355080" y="4406188"/>
+            <a:ext cx="5376672" cy="457200"/>
+          </a:xfrm>
+          <a:prstGeom prst="rect">
+            <a:avLst/>
+          </a:prstGeom>
+          <a:noFill/>
+        </p:spPr>
+        <p:txBody>
+          <a:bodyPr wrap="square">
+            <a:spAutoFit/>
+          </a:bodyPr>
+          <a:lstStyle/>
+          <a:p>
+            <a:pPr marL="0" indent="0">
+              <a:buNone/>
+            </a:pPr>
+            <a:r>
+              <a:rPr sz="1000" b="0">
+                <a:solidFill>
+                  <a:srgbClr val="555555"/>
+                </a:solidFill>
+                <a:latin typeface="Arial"/>
+              </a:rPr>
+              <a:t>Working prototype, fully offline: an unseen CIC-IDS2017 day turning critical as the DDoS begins.</a:t>
+            </a:r>
+          </a:p>
+        </p:txBody>
+      </p:sp>
+      <p:sp>
+        <p:nvSpPr>
+          <p:cNvPr id="10" name="Rounded Rectangle 9"/>
+          <p:cNvSpPr/>
+          <p:nvPr/>
+        </p:nvSpPr>
+        <p:spPr>
+          <a:xfrm>
+            <a:off x="457200" y="4983480"/>
+            <a:ext cx="2708910" cy="1234440"/>
+          </a:xfrm>
+          <a:prstGeom prst="roundRect">
+            <a:avLst>
+              <a:gd name="adj" fmla="val 7000"/>
+            </a:avLst>
+          </a:prstGeom>
+          <a:solidFill>
+            <a:srgbClr val="EEF3FA"/>
+          </a:solidFill>
+          <a:ln>
+            <a:noFill/>
+          </a:ln>
+          <a:effectLst/>
+        </p:spPr>
+        <p:style>
+          <a:lnRef idx="1">
+            <a:schemeClr val="accent1"/>
+          </a:lnRef>
+          <a:fillRef idx="3">
+            <a:schemeClr val="accent1"/>
+          </a:fillRef>
+          <a:effectRef idx="2">
+            <a:schemeClr val="accent1"/>
+          </a:effectRef>
+          <a:fontRef idx="minor">
+            <a:schemeClr val="lt1"/>
+          </a:fontRef>
+        </p:style>
+        <p:txBody>
+          <a:bodyPr rtlCol="0" anchor="ctr" wrap="square" lIns="128016" rIns="128016" tIns="64008" bIns="64008"/>
+          <a:lstStyle/>
+          <a:p>
+            <a:pPr algn="ctr" marL="0" indent="0">
+              <a:buNone/>
+            </a:pPr>
+            <a:r>
+              <a:rPr sz="2400" b="1">
+                <a:solidFill>
+                  <a:srgbClr val="1F4E9A"/>
+                </a:solidFill>
+                <a:latin typeface="Arial"/>
+              </a:rPr>
+              <a:t>54 / 201</a:t>
+            </a:r>
+          </a:p>
+          <a:p>
+            <a:pPr marL="0" indent="0" algn="ctr">
+              <a:spcBef>
+                <a:spcPts val="200"/>
+              </a:spcBef>
+              <a:buNone/>
+            </a:pPr>
+            <a:r>
+              <a:rPr sz="1050" b="0">
+                <a:solidFill>
+                  <a:srgbClr val="202020"/>
+                </a:solidFill>
+                <a:latin typeface="Arial"/>
+              </a:rPr>
+              <a:t>attack onsets forecast before they began (baseline: 17)</a:t>
+            </a:r>
+          </a:p>
+        </p:txBody>
+      </p:sp>
+      <p:sp>
+        <p:nvSpPr>
+          <p:cNvPr id="11" name="Rounded Rectangle 10"/>
+          <p:cNvSpPr/>
+          <p:nvPr/>
+        </p:nvSpPr>
+        <p:spPr>
+          <a:xfrm>
+            <a:off x="3312414" y="4983480"/>
+            <a:ext cx="2708910" cy="1234440"/>
+          </a:xfrm>
+          <a:prstGeom prst="roundRect">
+            <a:avLst>
+              <a:gd name="adj" fmla="val 7000"/>
+            </a:avLst>
+          </a:prstGeom>
+          <a:solidFill>
+            <a:srgbClr val="EEF3FA"/>
+          </a:solidFill>
+          <a:ln>
+            <a:noFill/>
+          </a:ln>
+          <a:effectLst/>
+        </p:spPr>
+        <p:style>
+          <a:lnRef idx="1">
+            <a:schemeClr val="accent1"/>
+          </a:lnRef>
+          <a:fillRef idx="3">
+            <a:schemeClr val="accent1"/>
+          </a:fillRef>
+          <a:effectRef idx="2">
+            <a:schemeClr val="accent1"/>
+          </a:effectRef>
+          <a:fontRef idx="minor">
+            <a:schemeClr val="lt1"/>
+          </a:fontRef>
+        </p:style>
+        <p:txBody>
+          <a:bodyPr rtlCol="0" anchor="ctr" wrap="square" lIns="128016" rIns="128016" tIns="64008" bIns="64008"/>
+          <a:lstStyle/>
+          <a:p>
+            <a:pPr algn="ctr" marL="0" indent="0">
+              <a:buNone/>
+            </a:pPr>
+            <a:r>
+              <a:rPr sz="2400" b="1">
+                <a:solidFill>
+                  <a:srgbClr val="1F4E9A"/>
+                </a:solidFill>
+                <a:latin typeface="Arial"/>
+              </a:rPr>
+              <a:t>0.70 vs 0.67</a:t>
+            </a:r>
+          </a:p>
+          <a:p>
+            <a:pPr marL="0" indent="0" algn="ctr">
+              <a:spcBef>
+                <a:spcPts val="200"/>
+              </a:spcBef>
+              <a:buNone/>
+            </a:pPr>
+            <a:r>
+              <a:rPr sz="1050" b="0">
+                <a:solidFill>
+                  <a:srgbClr val="202020"/>
+                </a:solidFill>
+                <a:latin typeface="Arial"/>
+              </a:rPr>
+              <a:t>macro forecast AUROC on unseen data vs the baseline</a:t>
+            </a:r>
+          </a:p>
+        </p:txBody>
+      </p:sp>
+      <p:sp>
+        <p:nvSpPr>
+          <p:cNvPr id="12" name="Rounded Rectangle 11"/>
+          <p:cNvSpPr/>
+          <p:nvPr/>
+        </p:nvSpPr>
+        <p:spPr>
+          <a:xfrm>
+            <a:off x="6167628" y="4983480"/>
+            <a:ext cx="2708910" cy="1234440"/>
+          </a:xfrm>
+          <a:prstGeom prst="roundRect">
+            <a:avLst>
+              <a:gd name="adj" fmla="val 7000"/>
+            </a:avLst>
+          </a:prstGeom>
+          <a:solidFill>
+            <a:srgbClr val="EEF3FA"/>
+          </a:solidFill>
+          <a:ln>
+            <a:noFill/>
+          </a:ln>
+          <a:effectLst/>
+        </p:spPr>
+        <p:style>
+          <a:lnRef idx="1">
+            <a:schemeClr val="accent1"/>
+          </a:lnRef>
+          <a:fillRef idx="3">
+            <a:schemeClr val="accent1"/>
+          </a:fillRef>
+          <a:effectRef idx="2">
+            <a:schemeClr val="accent1"/>
+          </a:effectRef>
+          <a:fontRef idx="minor">
+            <a:schemeClr val="lt1"/>
+          </a:fontRef>
+        </p:style>
+        <p:txBody>
+          <a:bodyPr rtlCol="0" anchor="ctr" wrap="square" lIns="128016" rIns="128016" tIns="64008" bIns="64008"/>
+          <a:lstStyle/>
+          <a:p>
+            <a:pPr algn="ctr" marL="0" indent="0">
+              <a:buNone/>
+            </a:pPr>
+            <a:r>
+              <a:rPr sz="2400" b="1">
+                <a:solidFill>
+                  <a:srgbClr val="1F4E9A"/>
+                </a:solidFill>
+                <a:latin typeface="Arial"/>
+              </a:rPr>
+              <a:t>7 of 7</a:t>
+            </a:r>
+          </a:p>
+          <a:p>
+            <a:pPr marL="0" indent="0" algn="ctr">
+              <a:spcBef>
+                <a:spcPts val="200"/>
+              </a:spcBef>
+              <a:buNone/>
+            </a:pPr>
+            <a:r>
+              <a:rPr sz="1050" b="0">
+                <a:solidFill>
+                  <a:srgbClr val="202020"/>
+                </a:solidFill>
+                <a:latin typeface="Arial"/>
+              </a:rPr>
+              <a:t>PS datasets in one model, tested on unseen traffic</a:t>
+            </a:r>
+          </a:p>
+        </p:txBody>
+      </p:sp>
+      <p:sp>
+        <p:nvSpPr>
+          <p:cNvPr id="13" name="Rounded Rectangle 12"/>
+          <p:cNvSpPr/>
+          <p:nvPr/>
+        </p:nvSpPr>
+        <p:spPr>
+          <a:xfrm>
+            <a:off x="9022842" y="4983480"/>
+            <a:ext cx="2708910" cy="1234440"/>
+          </a:xfrm>
+          <a:prstGeom prst="roundRect">
+            <a:avLst>
+              <a:gd name="adj" fmla="val 7000"/>
+            </a:avLst>
+          </a:prstGeom>
+          <a:solidFill>
+            <a:srgbClr val="EEF3FA"/>
+          </a:solidFill>
+          <a:ln>
+            <a:noFill/>
+          </a:ln>
+          <a:effectLst/>
+        </p:spPr>
+        <p:style>
+          <a:lnRef idx="1">
+            <a:schemeClr val="accent1"/>
+          </a:lnRef>
+          <a:fillRef idx="3">
+            <a:schemeClr val="accent1"/>
+          </a:fillRef>
+          <a:effectRef idx="2">
+            <a:schemeClr val="accent1"/>
+          </a:effectRef>
+          <a:fontRef idx="minor">
+            <a:schemeClr val="lt1"/>
+          </a:fontRef>
+        </p:style>
+        <p:txBody>
+          <a:bodyPr rtlCol="0" anchor="ctr" wrap="square" lIns="128016" rIns="128016" tIns="64008" bIns="64008"/>
+          <a:lstStyle/>
+          <a:p>
+            <a:pPr algn="ctr" marL="0" indent="0">
+              <a:buNone/>
+            </a:pPr>
+            <a:r>
+              <a:rPr sz="2400" b="1">
+                <a:solidFill>
+                  <a:srgbClr val="1F4E9A"/>
+                </a:solidFill>
+                <a:latin typeface="Arial"/>
+              </a:rPr>
+              <a:t>~8 ms</a:t>
+            </a:r>
+          </a:p>
+          <a:p>
+            <a:pPr marL="0" indent="0" algn="ctr">
+              <a:spcBef>
+                <a:spcPts val="200"/>
+              </a:spcBef>
+              <a:buNone/>
+            </a:pPr>
+            <a:r>
+              <a:rPr sz="1050" b="0">
+                <a:solidFill>
+                  <a:srgbClr val="202020"/>
+                </a:solidFill>
+                <a:latin typeface="Arial"/>
+              </a:rPr>
+              <a:t>per 10 s window on a laptop CPU</a:t>
             </a:r>
           </a:p>
         </p:txBody>
@@ -3292,14 +3783,6 @@
 <file path=ppt/slides/slide2.xml><?xml version="1.0" encoding="utf-8"?>
 <p:sld xmlns:a="http://schemas.openxmlformats.org/drawingml/2006/main" xmlns:p="http://schemas.openxmlformats.org/presentationml/2006/main" xmlns:r="http://schemas.openxmlformats.org/officeDocument/2006/relationships">
   <p:cSld>
-    <p:bg>
-      <p:bgPr>
-        <a:solidFill>
-          <a:srgbClr val="0E1116"/>
-        </a:solidFill>
-        <a:effectLst/>
-      </p:bgPr>
-    </p:bg>
     <p:spTree>
       <p:nvGrpSpPr>
         <p:cNvPr id="1" name=""/>
@@ -3307,52 +3790,9 @@
         <p:nvPr/>
       </p:nvGrpSpPr>
       <p:grpSpPr/>
-      <p:sp>
-        <p:nvSpPr>
-          <p:cNvPr id="2" name="TextBox 1"/>
-          <p:cNvSpPr txBox="1"/>
-          <p:nvPr/>
-        </p:nvSpPr>
-        <p:spPr>
-          <a:xfrm>
-            <a:off x="548640" y="320040"/>
-            <a:ext cx="11064240" cy="822960"/>
-          </a:xfrm>
-          <a:prstGeom prst="rect">
-            <a:avLst/>
-          </a:prstGeom>
-          <a:noFill/>
-        </p:spPr>
-        <p:txBody>
-          <a:bodyPr wrap="none">
-            <a:spAutoFit/>
-          </a:bodyPr>
-          <a:lstStyle/>
-          <a:p>
-            <a:r>
-              <a:rPr sz="3000" b="1">
-                <a:solidFill>
-                  <a:srgbClr val="E6EDF3"/>
-                </a:solidFill>
-              </a:rPr>
-              <a:t>Architecture: telemetry → network state → world model → forecast</a:t>
-            </a:r>
-          </a:p>
-          <a:p>
-            <a:r>
-              <a:rPr sz="1400">
-                <a:solidFill>
-                  <a:srgbClr val="2DD4BF"/>
-                </a:solidFill>
-              </a:rPr>
-              <a:t>any PS dataset format or PCAP · flow-level + packet-level features fused into S_t every 10 s (78 dims)</a:t>
-            </a:r>
-          </a:p>
-        </p:txBody>
-      </p:sp>
       <p:pic>
         <p:nvPicPr>
-          <p:cNvPr id="3" name="Picture 2" descr="architecture.png"/>
+          <p:cNvPr id="2" name="Picture 1" descr="logo_brown.png"/>
           <p:cNvPicPr>
             <a:picLocks noChangeAspect="1"/>
           </p:cNvPicPr>
@@ -3366,8 +3806,8 @@
         </p:blipFill>
         <p:spPr>
           <a:xfrm>
-            <a:off x="457200" y="1417320"/>
-            <a:ext cx="11247120" cy="4192108"/>
+            <a:off x="457200" y="329184"/>
+            <a:ext cx="537496" cy="603504"/>
           </a:xfrm>
           <a:prstGeom prst="rect">
             <a:avLst/>
@@ -3376,14 +3816,14 @@
       </p:pic>
       <p:sp>
         <p:nvSpPr>
-          <p:cNvPr id="4" name="TextBox 3"/>
+          <p:cNvPr id="3" name="TextBox 2"/>
           <p:cNvSpPr txBox="1"/>
           <p:nvPr/>
         </p:nvSpPr>
         <p:spPr>
           <a:xfrm>
-            <a:off x="548640" y="5669280"/>
-            <a:ext cx="11064240" cy="1097280"/>
+            <a:off x="1097280" y="237744"/>
+            <a:ext cx="10698480" cy="960120"/>
           </a:xfrm>
           <a:prstGeom prst="rect">
             <a:avLst/>
@@ -3396,49 +3836,398 @@
           </a:bodyPr>
           <a:lstStyle/>
           <a:p>
-            <a:pPr>
-              <a:spcAft>
-                <a:spcPts val="800"/>
-              </a:spcAft>
-            </a:pPr>
-            <a:r>
-              <a:rPr b="1" sz="1400">
-                <a:solidFill>
-                  <a:srgbClr val="2DD4BF"/>
-                </a:solidFill>
-              </a:rPr>
-              <a:t>Flow level:</a:t>
-            </a:r>
-            <a:r>
-              <a:rPr sz="1400">
-                <a:solidFill>
-                  <a:srgbClr val="E6EDF3"/>
-                </a:solidFill>
-              </a:rPr>
-              <a:t> 5-tuple, flags, bytes, packets, duration, IAT, fwd/bwd ratios + per-host maxima (a single bot is not diluted).</a:t>
-            </a:r>
-          </a:p>
-          <a:p>
-            <a:pPr>
-              <a:spcAft>
-                <a:spcPts val="800"/>
-              </a:spcAft>
-            </a:pPr>
-            <a:r>
-              <a:rPr b="1" sz="1400">
-                <a:solidFill>
-                  <a:srgbClr val="2DD4BF"/>
-                </a:solidFill>
-              </a:rPr>
-              <a:t>Packet level:</a:t>
-            </a:r>
-            <a:r>
-              <a:rPr sz="1400">
-                <a:solidFill>
-                  <a:srgbClr val="E6EDF3"/>
-                </a:solidFill>
-              </a:rPr>
-              <a:t> TTL &amp; session variance, TCP window, fragments, payload distribution, port-scan signatures, retransmissions.</a:t>
+            <a:pPr marL="0" indent="0">
+              <a:buNone/>
+            </a:pPr>
+            <a:r>
+              <a:rPr sz="2800" b="1">
+                <a:solidFill>
+                  <a:srgbClr val="202020"/>
+                </a:solidFill>
+                <a:latin typeface="Arial"/>
+              </a:rPr>
+              <a:t>Architecture: raw traffic to a forecast every 10 seconds</a:t>
+            </a:r>
+          </a:p>
+          <a:p>
+            <a:pPr marL="0" indent="0">
+              <a:spcBef>
+                <a:spcPts val="200"/>
+              </a:spcBef>
+              <a:buNone/>
+            </a:pPr>
+            <a:r>
+              <a:rPr sz="1350" b="0">
+                <a:solidFill>
+                  <a:srgbClr val="1F4E9A"/>
+                </a:solidFill>
+                <a:latin typeface="Arial"/>
+              </a:rPr>
+              <a:t>Flow records and/or packet captures → 78-dim network state S_t → world model → forecast, explanation, alert</a:t>
+            </a:r>
+          </a:p>
+        </p:txBody>
+      </p:sp>
+      <p:sp>
+        <p:nvSpPr>
+          <p:cNvPr id="4" name="Rectangle 3"/>
+          <p:cNvSpPr/>
+          <p:nvPr/>
+        </p:nvSpPr>
+        <p:spPr>
+          <a:xfrm>
+            <a:off x="457200" y="6391656"/>
+            <a:ext cx="11274552" cy="10972"/>
+          </a:xfrm>
+          <a:prstGeom prst="rect">
+            <a:avLst/>
+          </a:prstGeom>
+          <a:solidFill>
+            <a:srgbClr val="C9D3E3"/>
+          </a:solidFill>
+          <a:ln>
+            <a:noFill/>
+          </a:ln>
+          <a:effectLst/>
+        </p:spPr>
+        <p:style>
+          <a:lnRef idx="1">
+            <a:schemeClr val="accent1"/>
+          </a:lnRef>
+          <a:fillRef idx="3">
+            <a:schemeClr val="accent1"/>
+          </a:fillRef>
+          <a:effectRef idx="2">
+            <a:schemeClr val="accent1"/>
+          </a:effectRef>
+          <a:fontRef idx="minor">
+            <a:schemeClr val="lt1"/>
+          </a:fontRef>
+        </p:style>
+        <p:txBody>
+          <a:bodyPr rtlCol="0" anchor="ctr"/>
+          <a:lstStyle/>
+          <a:p>
+            <a:pPr algn="ctr"/>
+          </a:p>
+        </p:txBody>
+      </p:sp>
+      <p:sp>
+        <p:nvSpPr>
+          <p:cNvPr id="5" name="TextBox 4"/>
+          <p:cNvSpPr txBox="1"/>
+          <p:nvPr/>
+        </p:nvSpPr>
+        <p:spPr>
+          <a:xfrm>
+            <a:off x="457200" y="6419088"/>
+            <a:ext cx="9144000" cy="274320"/>
+          </a:xfrm>
+          <a:prstGeom prst="rect">
+            <a:avLst/>
+          </a:prstGeom>
+          <a:noFill/>
+        </p:spPr>
+        <p:txBody>
+          <a:bodyPr wrap="square">
+            <a:spAutoFit/>
+          </a:bodyPr>
+          <a:lstStyle/>
+          <a:p>
+            <a:pPr marL="0" indent="0">
+              <a:buNone/>
+            </a:pPr>
+            <a:r>
+              <a:rPr sz="900" b="0">
+                <a:solidFill>
+                  <a:srgbClr val="555555"/>
+                </a:solidFill>
+                <a:latin typeface="Arial"/>
+              </a:rPr>
+              <a:t>VIGHNAX · SIH 2026 · PS SIH26153 (NTRO) · Team ID 127364</a:t>
+            </a:r>
+          </a:p>
+        </p:txBody>
+      </p:sp>
+      <p:sp>
+        <p:nvSpPr>
+          <p:cNvPr id="6" name="TextBox 5"/>
+          <p:cNvSpPr txBox="1"/>
+          <p:nvPr/>
+        </p:nvSpPr>
+        <p:spPr>
+          <a:xfrm>
+            <a:off x="10789920" y="6419088"/>
+            <a:ext cx="941832" cy="274320"/>
+          </a:xfrm>
+          <a:prstGeom prst="rect">
+            <a:avLst/>
+          </a:prstGeom>
+          <a:noFill/>
+        </p:spPr>
+        <p:txBody>
+          <a:bodyPr wrap="square">
+            <a:spAutoFit/>
+          </a:bodyPr>
+          <a:lstStyle/>
+          <a:p>
+            <a:pPr marL="0" indent="0" algn="r">
+              <a:buNone/>
+            </a:pPr>
+            <a:r>
+              <a:rPr sz="900" b="0">
+                <a:solidFill>
+                  <a:srgbClr val="555555"/>
+                </a:solidFill>
+                <a:latin typeface="Arial"/>
+              </a:rPr>
+              <a:t>2 / 5</a:t>
+            </a:r>
+          </a:p>
+        </p:txBody>
+      </p:sp>
+      <p:pic>
+        <p:nvPicPr>
+          <p:cNvPr id="7" name="Picture 6" descr="architecture.png"/>
+          <p:cNvPicPr>
+            <a:picLocks noChangeAspect="1"/>
+          </p:cNvPicPr>
+          <p:nvPr/>
+        </p:nvPicPr>
+        <p:blipFill>
+          <a:blip r:embed="rId3"/>
+          <a:stretch>
+            <a:fillRect/>
+          </a:stretch>
+        </p:blipFill>
+        <p:spPr>
+          <a:xfrm>
+            <a:off x="792327" y="1325880"/>
+            <a:ext cx="10607040" cy="3953533"/>
+          </a:xfrm>
+          <a:prstGeom prst="rect">
+            <a:avLst/>
+          </a:prstGeom>
+        </p:spPr>
+      </p:pic>
+      <p:sp>
+        <p:nvSpPr>
+          <p:cNvPr id="8" name="Rounded Rectangle 7"/>
+          <p:cNvSpPr/>
+          <p:nvPr/>
+        </p:nvSpPr>
+        <p:spPr>
+          <a:xfrm>
+            <a:off x="457200" y="5349240"/>
+            <a:ext cx="3660647" cy="914400"/>
+          </a:xfrm>
+          <a:prstGeom prst="roundRect">
+            <a:avLst>
+              <a:gd name="adj" fmla="val 7000"/>
+            </a:avLst>
+          </a:prstGeom>
+          <a:solidFill>
+            <a:srgbClr val="EEF3FA"/>
+          </a:solidFill>
+          <a:ln>
+            <a:noFill/>
+          </a:ln>
+          <a:effectLst/>
+        </p:spPr>
+        <p:style>
+          <a:lnRef idx="1">
+            <a:schemeClr val="accent1"/>
+          </a:lnRef>
+          <a:fillRef idx="3">
+            <a:schemeClr val="accent1"/>
+          </a:fillRef>
+          <a:effectRef idx="2">
+            <a:schemeClr val="accent1"/>
+          </a:effectRef>
+          <a:fontRef idx="minor">
+            <a:schemeClr val="lt1"/>
+          </a:fontRef>
+        </p:style>
+        <p:txBody>
+          <a:bodyPr rtlCol="0" anchor="t" wrap="square" lIns="164592" rIns="164592" tIns="128016" bIns="64008"/>
+          <a:lstStyle/>
+          <a:p>
+            <a:pPr algn="l" marL="0" indent="0">
+              <a:buNone/>
+            </a:pPr>
+            <a:r>
+              <a:rPr sz="1200" b="1">
+                <a:solidFill>
+                  <a:srgbClr val="1F4E9A"/>
+                </a:solidFill>
+                <a:latin typeface="Arial"/>
+              </a:rPr>
+              <a:t>Flow level: 47 features</a:t>
+            </a:r>
+          </a:p>
+          <a:p>
+            <a:pPr marL="0" indent="0" algn="l">
+              <a:spcBef>
+                <a:spcPts val="300"/>
+              </a:spcBef>
+              <a:buNone/>
+            </a:pPr>
+            <a:r>
+              <a:rPr sz="1100" b="0">
+                <a:solidFill>
+                  <a:srgbClr val="202020"/>
+                </a:solidFill>
+                <a:latin typeface="Arial"/>
+              </a:rPr>
+              <a:t>5-tuple statistics, flags, bytes, packets, duration, IAT, fwd/bwd ratios, per-host maxima so one bot is not diluted</a:t>
+            </a:r>
+          </a:p>
+        </p:txBody>
+      </p:sp>
+      <p:sp>
+        <p:nvSpPr>
+          <p:cNvPr id="9" name="Rounded Rectangle 8"/>
+          <p:cNvSpPr/>
+          <p:nvPr/>
+        </p:nvSpPr>
+        <p:spPr>
+          <a:xfrm>
+            <a:off x="4264152" y="5349240"/>
+            <a:ext cx="3660647" cy="914400"/>
+          </a:xfrm>
+          <a:prstGeom prst="roundRect">
+            <a:avLst>
+              <a:gd name="adj" fmla="val 7000"/>
+            </a:avLst>
+          </a:prstGeom>
+          <a:solidFill>
+            <a:srgbClr val="EEF3FA"/>
+          </a:solidFill>
+          <a:ln>
+            <a:noFill/>
+          </a:ln>
+          <a:effectLst/>
+        </p:spPr>
+        <p:style>
+          <a:lnRef idx="1">
+            <a:schemeClr val="accent1"/>
+          </a:lnRef>
+          <a:fillRef idx="3">
+            <a:schemeClr val="accent1"/>
+          </a:fillRef>
+          <a:effectRef idx="2">
+            <a:schemeClr val="accent1"/>
+          </a:effectRef>
+          <a:fontRef idx="minor">
+            <a:schemeClr val="lt1"/>
+          </a:fontRef>
+        </p:style>
+        <p:txBody>
+          <a:bodyPr rtlCol="0" anchor="t" wrap="square" lIns="164592" rIns="164592" tIns="128016" bIns="64008"/>
+          <a:lstStyle/>
+          <a:p>
+            <a:pPr algn="l" marL="0" indent="0">
+              <a:buNone/>
+            </a:pPr>
+            <a:r>
+              <a:rPr sz="1200" b="1">
+                <a:solidFill>
+                  <a:srgbClr val="1F4E9A"/>
+                </a:solidFill>
+                <a:latin typeface="Arial"/>
+              </a:rPr>
+              <a:t>Packet level: 30 features</a:t>
+            </a:r>
+          </a:p>
+          <a:p>
+            <a:pPr marL="0" indent="0" algn="l">
+              <a:spcBef>
+                <a:spcPts val="300"/>
+              </a:spcBef>
+              <a:buNone/>
+            </a:pPr>
+            <a:r>
+              <a:rPr sz="1100" b="0">
+                <a:solidFill>
+                  <a:srgbClr val="202020"/>
+                </a:solidFill>
+                <a:latin typeface="Arial"/>
+              </a:rPr>
+              <a:t>TTL and session variance, TCP window, fragments, payload sizes, port-scan signatures, retransmissions</a:t>
+            </a:r>
+          </a:p>
+        </p:txBody>
+      </p:sp>
+      <p:sp>
+        <p:nvSpPr>
+          <p:cNvPr id="10" name="Rounded Rectangle 9"/>
+          <p:cNvSpPr/>
+          <p:nvPr/>
+        </p:nvSpPr>
+        <p:spPr>
+          <a:xfrm>
+            <a:off x="8071104" y="5349240"/>
+            <a:ext cx="3660647" cy="914400"/>
+          </a:xfrm>
+          <a:prstGeom prst="roundRect">
+            <a:avLst>
+              <a:gd name="adj" fmla="val 7000"/>
+            </a:avLst>
+          </a:prstGeom>
+          <a:solidFill>
+            <a:srgbClr val="EEF3FA"/>
+          </a:solidFill>
+          <a:ln>
+            <a:noFill/>
+          </a:ln>
+          <a:effectLst/>
+        </p:spPr>
+        <p:style>
+          <a:lnRef idx="1">
+            <a:schemeClr val="accent1"/>
+          </a:lnRef>
+          <a:fillRef idx="3">
+            <a:schemeClr val="accent1"/>
+          </a:fillRef>
+          <a:effectRef idx="2">
+            <a:schemeClr val="accent1"/>
+          </a:effectRef>
+          <a:fontRef idx="minor">
+            <a:schemeClr val="lt1"/>
+          </a:fontRef>
+        </p:style>
+        <p:txBody>
+          <a:bodyPr rtlCol="0" anchor="t" wrap="square" lIns="164592" rIns="164592" tIns="128016" bIns="64008"/>
+          <a:lstStyle/>
+          <a:p>
+            <a:pPr algn="l" marL="0" indent="0">
+              <a:buNone/>
+            </a:pPr>
+            <a:r>
+              <a:rPr sz="1200" b="1">
+                <a:solidFill>
+                  <a:srgbClr val="1F4E9A"/>
+                </a:solidFill>
+                <a:latin typeface="Arial"/>
+              </a:rPr>
+              <a:t>Ingestion</a:t>
+            </a:r>
+          </a:p>
+          <a:p>
+            <a:pPr marL="0" indent="0" algn="l">
+              <a:spcBef>
+                <a:spcPts val="300"/>
+              </a:spcBef>
+              <a:buNone/>
+            </a:pPr>
+            <a:r>
+              <a:rPr sz="1100" b="0">
+                <a:solidFill>
+                  <a:srgbClr val="202020"/>
+                </a:solidFill>
+                <a:latin typeface="Arial"/>
+              </a:rPr>
+              <a:t>every PS dataset's native format, detected by content; PCAP / PCAPNG streamed at ~125k packets/s</a:t>
             </a:r>
           </a:p>
         </p:txBody>
@@ -3454,14 +4243,6 @@
 <file path=ppt/slides/slide3.xml><?xml version="1.0" encoding="utf-8"?>
 <p:sld xmlns:a="http://schemas.openxmlformats.org/drawingml/2006/main" xmlns:p="http://schemas.openxmlformats.org/presentationml/2006/main" xmlns:r="http://schemas.openxmlformats.org/officeDocument/2006/relationships">
   <p:cSld>
-    <p:bg>
-      <p:bgPr>
-        <a:solidFill>
-          <a:srgbClr val="0E1116"/>
-        </a:solidFill>
-        <a:effectLst/>
-      </p:bgPr>
-    </p:bg>
     <p:spTree>
       <p:nvGrpSpPr>
         <p:cNvPr id="1" name=""/>
@@ -3469,16 +4250,40 @@
         <p:nvPr/>
       </p:nvGrpSpPr>
       <p:grpSpPr/>
-      <p:sp>
-        <p:nvSpPr>
-          <p:cNvPr id="2" name="TextBox 1"/>
+      <p:pic>
+        <p:nvPicPr>
+          <p:cNvPr id="2" name="Picture 1" descr="logo_brown.png"/>
+          <p:cNvPicPr>
+            <a:picLocks noChangeAspect="1"/>
+          </p:cNvPicPr>
+          <p:nvPr/>
+        </p:nvPicPr>
+        <p:blipFill>
+          <a:blip r:embed="rId2"/>
+          <a:stretch>
+            <a:fillRect/>
+          </a:stretch>
+        </p:blipFill>
+        <p:spPr>
+          <a:xfrm>
+            <a:off x="457200" y="329184"/>
+            <a:ext cx="537496" cy="603504"/>
+          </a:xfrm>
+          <a:prstGeom prst="rect">
+            <a:avLst/>
+          </a:prstGeom>
+        </p:spPr>
+      </p:pic>
+      <p:sp>
+        <p:nvSpPr>
+          <p:cNvPr id="3" name="TextBox 2"/>
           <p:cNvSpPr txBox="1"/>
           <p:nvPr/>
         </p:nvSpPr>
         <p:spPr>
           <a:xfrm>
-            <a:off x="548640" y="320040"/>
-            <a:ext cx="11064240" cy="822960"/>
+            <a:off x="1097280" y="237744"/>
+            <a:ext cx="10698480" cy="960120"/>
           </a:xfrm>
           <a:prstGeom prst="rect">
             <a:avLst/>
@@ -3486,42 +4291,97 @@
           <a:noFill/>
         </p:spPr>
         <p:txBody>
-          <a:bodyPr wrap="none">
+          <a:bodyPr wrap="square">
             <a:spAutoFit/>
           </a:bodyPr>
           <a:lstStyle/>
           <a:p>
-            <a:r>
-              <a:rPr sz="3000" b="1">
-                <a:solidFill>
-                  <a:srgbClr val="E6EDF3"/>
-                </a:solidFill>
+            <a:pPr marL="0" indent="0">
+              <a:buNone/>
+            </a:pPr>
+            <a:r>
+              <a:rPr sz="2800" b="1">
+                <a:solidFill>
+                  <a:srgbClr val="202020"/>
+                </a:solidFill>
+                <a:latin typeface="Arial"/>
               </a:rPr>
               <a:t>World model: learn the dynamics, then imagine the future</a:t>
             </a:r>
           </a:p>
           <a:p>
-            <a:r>
-              <a:rPr sz="1400">
-                <a:solidFill>
-                  <a:srgbClr val="2DD4BF"/>
-                </a:solidFill>
-              </a:rPr>
-              <a:t>RSSM-style latent state-space model (cf. World Models, Dreamer), trained on seven datasets' attack timelines</a:t>
-            </a:r>
-          </a:p>
-        </p:txBody>
-      </p:sp>
-      <p:sp>
-        <p:nvSpPr>
-          <p:cNvPr id="3" name="TextBox 2"/>
+            <a:pPr marL="0" indent="0">
+              <a:spcBef>
+                <a:spcPts val="200"/>
+              </a:spcBef>
+              <a:buNone/>
+            </a:pPr>
+            <a:r>
+              <a:rPr sz="1350" b="0">
+                <a:solidFill>
+                  <a:srgbClr val="1F4E9A"/>
+                </a:solidFill>
+                <a:latin typeface="Arial"/>
+              </a:rPr>
+              <a:t>RSSM-style latent state-space model (after World Models and Dreamer), trained on the attack timelines of all seven datasets</a:t>
+            </a:r>
+          </a:p>
+        </p:txBody>
+      </p:sp>
+      <p:sp>
+        <p:nvSpPr>
+          <p:cNvPr id="4" name="Rectangle 3"/>
+          <p:cNvSpPr/>
+          <p:nvPr/>
+        </p:nvSpPr>
+        <p:spPr>
+          <a:xfrm>
+            <a:off x="457200" y="6391656"/>
+            <a:ext cx="11274552" cy="10972"/>
+          </a:xfrm>
+          <a:prstGeom prst="rect">
+            <a:avLst/>
+          </a:prstGeom>
+          <a:solidFill>
+            <a:srgbClr val="C9D3E3"/>
+          </a:solidFill>
+          <a:ln>
+            <a:noFill/>
+          </a:ln>
+          <a:effectLst/>
+        </p:spPr>
+        <p:style>
+          <a:lnRef idx="1">
+            <a:schemeClr val="accent1"/>
+          </a:lnRef>
+          <a:fillRef idx="3">
+            <a:schemeClr val="accent1"/>
+          </a:fillRef>
+          <a:effectRef idx="2">
+            <a:schemeClr val="accent1"/>
+          </a:effectRef>
+          <a:fontRef idx="minor">
+            <a:schemeClr val="lt1"/>
+          </a:fontRef>
+        </p:style>
+        <p:txBody>
+          <a:bodyPr rtlCol="0" anchor="ctr"/>
+          <a:lstStyle/>
+          <a:p>
+            <a:pPr algn="ctr"/>
+          </a:p>
+        </p:txBody>
+      </p:sp>
+      <p:sp>
+        <p:nvSpPr>
+          <p:cNvPr id="5" name="TextBox 4"/>
           <p:cNvSpPr txBox="1"/>
           <p:nvPr/>
         </p:nvSpPr>
         <p:spPr>
           <a:xfrm>
-            <a:off x="548640" y="1600200"/>
-            <a:ext cx="11064240" cy="5029200"/>
+            <a:off x="457200" y="6419088"/>
+            <a:ext cx="9144000" cy="274320"/>
           </a:xfrm>
           <a:prstGeom prst="rect">
             <a:avLst/>
@@ -3534,145 +4394,483 @@
           </a:bodyPr>
           <a:lstStyle/>
           <a:p>
-            <a:pPr>
-              <a:spcAft>
-                <a:spcPts val="800"/>
-              </a:spcAft>
-            </a:pPr>
-            <a:r>
-              <a:rPr b="1" sz="1900">
-                <a:solidFill>
-                  <a:srgbClr val="2DD4BF"/>
-                </a:solidFill>
-              </a:rPr>
-              <a:t>Transition model:</a:t>
-            </a:r>
-            <a:r>
-              <a:rPr sz="1900">
-                <a:solidFill>
-                  <a:srgbClr val="E6EDF3"/>
-                </a:solidFill>
-              </a:rPr>
-              <a:t> encoder q(z_t|S_t), GRU memory h_t, prior p(z_t+1|h_t+1) (learned transition distribution), decoder p(S|z).</a:t>
-            </a:r>
-          </a:p>
-          <a:p>
-            <a:pPr>
-              <a:spcAft>
-                <a:spcPts val="800"/>
-              </a:spcAft>
-            </a:pPr>
-            <a:r>
-              <a:rPr b="1" sz="1900">
-                <a:solidFill>
-                  <a:srgbClr val="2DD4BF"/>
-                </a:solidFill>
-              </a:rPr>
-              <a:t>Supervised dynamics:</a:t>
-            </a:r>
-            <a:r>
-              <a:rPr sz="1900">
-                <a:solidFill>
-                  <a:srgbClr val="E6EDF3"/>
-                </a:solidFill>
-              </a:rPr>
-              <a:t> attack + ATT&amp;CK-stage heads trained on observed states AND on imagined K-step rollouts against the true future labels.</a:t>
-            </a:r>
-          </a:p>
-          <a:p>
-            <a:pPr>
-              <a:spcAft>
-                <a:spcPts val="800"/>
-              </a:spcAft>
-            </a:pPr>
-            <a:r>
-              <a:rPr b="1" sz="1900">
-                <a:solidFill>
-                  <a:srgbClr val="2DD4BF"/>
-                </a:solidFill>
-              </a:rPr>
-              <a:t>Forward simulation:</a:t>
-            </a:r>
-            <a:r>
-              <a:rPr sz="1900">
-                <a:solidFill>
-                  <a:srgbClr val="E6EDF3"/>
-                </a:solidFill>
-              </a:rPr>
-              <a:t> 32 Monte-Carlo trajectories, K = 6 x 10 s: probability per future window, 10–90 % band, stage mix.</a:t>
-            </a:r>
-          </a:p>
-          <a:p>
-            <a:pPr>
-              <a:spcAft>
-                <a:spcPts val="800"/>
-              </a:spcAft>
-            </a:pPr>
-            <a:r>
-              <a:rPr b="1" sz="1900">
-                <a:solidFill>
-                  <a:srgbClr val="2DD4BF"/>
-                </a:solidFill>
-              </a:rPr>
-              <a:t>Explainability:</a:t>
-            </a:r>
-            <a:r>
-              <a:rPr sz="1900">
-                <a:solidFill>
-                  <a:srgbClr val="E6EDF3"/>
-                </a:solidFill>
-              </a:rPr>
-              <a:t> Integrated Gradients (Aumann–Shapley/SHAP family) vs a benign reference state; host-occlusion flags the responsible hosts.</a:t>
-            </a:r>
-          </a:p>
-          <a:p>
-            <a:pPr>
-              <a:spcAft>
-                <a:spcPts val="800"/>
-              </a:spcAft>
-            </a:pPr>
-            <a:r>
-              <a:rPr b="1" sz="1900">
-                <a:solidFill>
-                  <a:srgbClr val="2DD4BF"/>
-                </a:solidFill>
-              </a:rPr>
-              <a:t>Robustness:</a:t>
-            </a:r>
-            <a:r>
-              <a:rPr sz="1900">
-                <a:solidFill>
-                  <a:srgbClr val="E6EDF3"/>
-                </a:solidFill>
-              </a:rPr>
-              <a:t> dataset-balanced training, modality dropout (CSV-only inputs), volume augmentation, per-site alert calibration.</a:t>
-            </a:r>
-          </a:p>
-          <a:p>
-            <a:pPr>
-              <a:spcAft>
-                <a:spcPts val="800"/>
-              </a:spcAft>
-            </a:pPr>
-            <a:r>
-              <a:rPr b="1" sz="1900">
-                <a:solidFill>
-                  <a:srgbClr val="2DD4BF"/>
-                </a:solidFill>
-              </a:rPr>
-              <a:t>Stages:</a:t>
-            </a:r>
-            <a:r>
-              <a:rPr sz="1900">
-                <a:solidFill>
-                  <a:srgbClr val="E6EDF3"/>
-                </a:solidFill>
-              </a:rPr>
-              <a:t> Recon · Initial Access · Lateral Movement · C2 · Exfiltration · Impact — all present across the seven datasets.</a:t>
-            </a:r>
-          </a:p>
-        </p:txBody>
-      </p:sp>
+            <a:pPr marL="0" indent="0">
+              <a:buNone/>
+            </a:pPr>
+            <a:r>
+              <a:rPr sz="900" b="0">
+                <a:solidFill>
+                  <a:srgbClr val="555555"/>
+                </a:solidFill>
+                <a:latin typeface="Arial"/>
+              </a:rPr>
+              <a:t>VIGHNAX · SIH 2026 · PS SIH26153 (NTRO) · Team ID 127364</a:t>
+            </a:r>
+          </a:p>
+        </p:txBody>
+      </p:sp>
+      <p:sp>
+        <p:nvSpPr>
+          <p:cNvPr id="6" name="TextBox 5"/>
+          <p:cNvSpPr txBox="1"/>
+          <p:nvPr/>
+        </p:nvSpPr>
+        <p:spPr>
+          <a:xfrm>
+            <a:off x="10789920" y="6419088"/>
+            <a:ext cx="941832" cy="274320"/>
+          </a:xfrm>
+          <a:prstGeom prst="rect">
+            <a:avLst/>
+          </a:prstGeom>
+          <a:noFill/>
+        </p:spPr>
+        <p:txBody>
+          <a:bodyPr wrap="square">
+            <a:spAutoFit/>
+          </a:bodyPr>
+          <a:lstStyle/>
+          <a:p>
+            <a:pPr marL="0" indent="0" algn="r">
+              <a:buNone/>
+            </a:pPr>
+            <a:r>
+              <a:rPr sz="900" b="0">
+                <a:solidFill>
+                  <a:srgbClr val="555555"/>
+                </a:solidFill>
+                <a:latin typeface="Arial"/>
+              </a:rPr>
+              <a:t>3 / 5</a:t>
+            </a:r>
+          </a:p>
+        </p:txBody>
+      </p:sp>
+      <p:sp>
+        <p:nvSpPr>
+          <p:cNvPr id="7" name="TextBox 6"/>
+          <p:cNvSpPr txBox="1"/>
+          <p:nvPr/>
+        </p:nvSpPr>
+        <p:spPr>
+          <a:xfrm>
+            <a:off x="457200" y="1371600"/>
+            <a:ext cx="5074920" cy="4572000"/>
+          </a:xfrm>
+          <a:prstGeom prst="rect">
+            <a:avLst/>
+          </a:prstGeom>
+          <a:noFill/>
+        </p:spPr>
+        <p:txBody>
+          <a:bodyPr wrap="square">
+            <a:spAutoFit/>
+          </a:bodyPr>
+          <a:lstStyle/>
+          <a:p>
+            <a:pPr marL="0" indent="0">
+              <a:buNone/>
+            </a:pPr>
+            <a:r>
+              <a:rPr sz="1150" b="1">
+                <a:solidFill>
+                  <a:srgbClr val="1F4E9A"/>
+                </a:solidFill>
+                <a:latin typeface="Arial"/>
+              </a:rPr>
+              <a:t>TRANSITION MODEL</a:t>
+            </a:r>
+          </a:p>
+          <a:p>
+            <a:pPr marL="0" indent="0">
+              <a:spcBef>
+                <a:spcPts val="100"/>
+              </a:spcBef>
+              <a:buNone/>
+            </a:pPr>
+            <a:r>
+              <a:rPr sz="1300" b="0">
+                <a:solidFill>
+                  <a:srgbClr val="202020"/>
+                </a:solidFill>
+                <a:latin typeface="Arial"/>
+              </a:rPr>
+              <a:t>encoder q(z_t | S_t) → GRU memory h_t → learned prior p(z_t+1 | h_t+1) → decoder p(S | z)</a:t>
+            </a:r>
+          </a:p>
+          <a:p>
+            <a:pPr marL="0" indent="0">
+              <a:spcBef>
+                <a:spcPts val="700"/>
+              </a:spcBef>
+              <a:buNone/>
+            </a:pPr>
+            <a:r>
+              <a:rPr sz="1150" b="1">
+                <a:solidFill>
+                  <a:srgbClr val="1F4E9A"/>
+                </a:solidFill>
+                <a:latin typeface="Arial"/>
+              </a:rPr>
+              <a:t>TRAINED ON IMAGINED FUTURES</a:t>
+            </a:r>
+          </a:p>
+          <a:p>
+            <a:pPr marL="0" indent="0">
+              <a:spcBef>
+                <a:spcPts val="100"/>
+              </a:spcBef>
+              <a:buNone/>
+            </a:pPr>
+            <a:r>
+              <a:rPr sz="1300" b="0">
+                <a:solidFill>
+                  <a:srgbClr val="202020"/>
+                </a:solidFill>
+                <a:latin typeface="Arial"/>
+              </a:rPr>
+              <a:t>attack and ATT&amp;CK-stage heads are scored on observed states and on K-step rollouts against the true future labels</a:t>
+            </a:r>
+          </a:p>
+          <a:p>
+            <a:pPr marL="0" indent="0">
+              <a:spcBef>
+                <a:spcPts val="700"/>
+              </a:spcBef>
+              <a:buNone/>
+            </a:pPr>
+            <a:r>
+              <a:rPr sz="1150" b="1">
+                <a:solidFill>
+                  <a:srgbClr val="1F4E9A"/>
+                </a:solidFill>
+                <a:latin typeface="Arial"/>
+              </a:rPr>
+              <a:t>FORWARD SIMULATION</a:t>
+            </a:r>
+          </a:p>
+          <a:p>
+            <a:pPr marL="0" indent="0">
+              <a:spcBef>
+                <a:spcPts val="100"/>
+              </a:spcBef>
+              <a:buNone/>
+            </a:pPr>
+            <a:r>
+              <a:rPr sz="1300" b="0">
+                <a:solidFill>
+                  <a:srgbClr val="202020"/>
+                </a:solidFill>
+                <a:latin typeface="Arial"/>
+              </a:rPr>
+              <a:t>32 Monte-Carlo futures × 6 steps (60 s): probability per window, 10–90 % band, stage mix</a:t>
+            </a:r>
+          </a:p>
+          <a:p>
+            <a:pPr marL="0" indent="0">
+              <a:spcBef>
+                <a:spcPts val="700"/>
+              </a:spcBef>
+              <a:buNone/>
+            </a:pPr>
+            <a:r>
+              <a:rPr sz="1150" b="1">
+                <a:solidFill>
+                  <a:srgbClr val="1F4E9A"/>
+                </a:solidFill>
+                <a:latin typeface="Arial"/>
+              </a:rPr>
+              <a:t>EXPLANATIONS</a:t>
+            </a:r>
+          </a:p>
+          <a:p>
+            <a:pPr marL="0" indent="0">
+              <a:spcBef>
+                <a:spcPts val="100"/>
+              </a:spcBef>
+              <a:buNone/>
+            </a:pPr>
+            <a:r>
+              <a:rPr sz="1300" b="0">
+                <a:solidFill>
+                  <a:srgbClr val="202020"/>
+                </a:solidFill>
+                <a:latin typeface="Arial"/>
+              </a:rPr>
+              <a:t>Integrated Gradients against a benign reference state; each host removed in turn to rank who drives the alert</a:t>
+            </a:r>
+          </a:p>
+          <a:p>
+            <a:pPr marL="0" indent="0">
+              <a:spcBef>
+                <a:spcPts val="700"/>
+              </a:spcBef>
+              <a:buNone/>
+            </a:pPr>
+            <a:r>
+              <a:rPr sz="1150" b="1">
+                <a:solidFill>
+                  <a:srgbClr val="1F4E9A"/>
+                </a:solidFill>
+                <a:latin typeface="Arial"/>
+              </a:rPr>
+              <a:t>ROBUSTNESS</a:t>
+            </a:r>
+          </a:p>
+          <a:p>
+            <a:pPr marL="0" indent="0">
+              <a:spcBef>
+                <a:spcPts val="100"/>
+              </a:spcBef>
+              <a:buNone/>
+            </a:pPr>
+            <a:r>
+              <a:rPr sz="1300" b="0">
+                <a:solidFill>
+                  <a:srgbClr val="202020"/>
+                </a:solidFill>
+                <a:latin typeface="Arial"/>
+              </a:rPr>
+              <a:t>dataset-balanced training, modality dropout (CSV-only input), volume augmentation, per-site alert thresholds</a:t>
+            </a:r>
+          </a:p>
+        </p:txBody>
+      </p:sp>
+      <p:sp>
+        <p:nvSpPr>
+          <p:cNvPr id="8" name="TextBox 7"/>
+          <p:cNvSpPr txBox="1"/>
+          <p:nvPr/>
+        </p:nvSpPr>
+        <p:spPr>
+          <a:xfrm>
+            <a:off x="457200" y="5943600"/>
+            <a:ext cx="5074920" cy="365760"/>
+          </a:xfrm>
+          <a:prstGeom prst="rect">
+            <a:avLst/>
+          </a:prstGeom>
+          <a:noFill/>
+        </p:spPr>
+        <p:txBody>
+          <a:bodyPr wrap="square">
+            <a:spAutoFit/>
+          </a:bodyPr>
+          <a:lstStyle/>
+          <a:p>
+            <a:pPr marL="0" indent="0">
+              <a:buNone/>
+            </a:pPr>
+            <a:r>
+              <a:rPr sz="1000" b="0">
+                <a:solidFill>
+                  <a:srgbClr val="555555"/>
+                </a:solidFill>
+                <a:latin typeface="Arial"/>
+              </a:rPr>
+              <a:t>Panels: real output at the DDoS onset of an unseen CIC-IDS2017 day.</a:t>
+            </a:r>
+          </a:p>
+        </p:txBody>
+      </p:sp>
+      <p:sp>
+        <p:nvSpPr>
+          <p:cNvPr id="9" name="TextBox 8"/>
+          <p:cNvSpPr txBox="1"/>
+          <p:nvPr/>
+        </p:nvSpPr>
+        <p:spPr>
+          <a:xfrm>
+            <a:off x="5806440" y="1325880"/>
+            <a:ext cx="5879592" cy="274320"/>
+          </a:xfrm>
+          <a:prstGeom prst="rect">
+            <a:avLst/>
+          </a:prstGeom>
+          <a:noFill/>
+        </p:spPr>
+        <p:txBody>
+          <a:bodyPr wrap="square">
+            <a:spAutoFit/>
+          </a:bodyPr>
+          <a:lstStyle/>
+          <a:p>
+            <a:pPr marL="0" indent="0">
+              <a:buNone/>
+            </a:pPr>
+            <a:r>
+              <a:rPr sz="1100" b="1">
+                <a:solidFill>
+                  <a:srgbClr val="555555"/>
+                </a:solidFill>
+                <a:latin typeface="Arial"/>
+              </a:rPr>
+              <a:t>WHAT HAPPENS NEXT · 32 futures, 60 s ahead</a:t>
+            </a:r>
+          </a:p>
+        </p:txBody>
+      </p:sp>
+      <p:pic>
+        <p:nvPicPr>
+          <p:cNvPr id="10" name="Picture 9" descr="panel_sim.png"/>
+          <p:cNvPicPr>
+            <a:picLocks noChangeAspect="1"/>
+          </p:cNvPicPr>
+          <p:nvPr/>
+        </p:nvPicPr>
+        <p:blipFill>
+          <a:blip r:embed="rId3"/>
+          <a:stretch>
+            <a:fillRect/>
+          </a:stretch>
+        </p:blipFill>
+        <p:spPr>
+          <a:xfrm>
+            <a:off x="5852160" y="1581912"/>
+            <a:ext cx="5879592" cy="1469898"/>
+          </a:xfrm>
+          <a:prstGeom prst="rect">
+            <a:avLst/>
+          </a:prstGeom>
+          <a:ln w="9525">
+            <a:solidFill>
+              <a:srgbClr val="C9D3E3"/>
+            </a:solidFill>
+          </a:ln>
+        </p:spPr>
+      </p:pic>
+      <p:sp>
+        <p:nvSpPr>
+          <p:cNvPr id="11" name="TextBox 10"/>
+          <p:cNvSpPr txBox="1"/>
+          <p:nvPr/>
+        </p:nvSpPr>
+        <p:spPr>
+          <a:xfrm>
+            <a:off x="5806440" y="3143250"/>
+            <a:ext cx="5879592" cy="274320"/>
+          </a:xfrm>
+          <a:prstGeom prst="rect">
+            <a:avLst/>
+          </a:prstGeom>
+          <a:noFill/>
+        </p:spPr>
+        <p:txBody>
+          <a:bodyPr wrap="square">
+            <a:spAutoFit/>
+          </a:bodyPr>
+          <a:lstStyle/>
+          <a:p>
+            <a:pPr marL="0" indent="0">
+              <a:buNone/>
+            </a:pPr>
+            <a:r>
+              <a:rPr sz="1100" b="1">
+                <a:solidFill>
+                  <a:srgbClr val="555555"/>
+                </a:solidFill>
+                <a:latin typeface="Arial"/>
+              </a:rPr>
+              <a:t>WHY · Integrated Gradients (red → compromise, blue → normal)</a:t>
+            </a:r>
+          </a:p>
+        </p:txBody>
+      </p:sp>
+      <p:pic>
+        <p:nvPicPr>
+          <p:cNvPr id="12" name="Picture 11" descr="panel_why.png"/>
+          <p:cNvPicPr>
+            <a:picLocks noChangeAspect="1"/>
+          </p:cNvPicPr>
+          <p:nvPr/>
+        </p:nvPicPr>
+        <p:blipFill>
+          <a:blip r:embed="rId4"/>
+          <a:stretch>
+            <a:fillRect/>
+          </a:stretch>
+        </p:blipFill>
+        <p:spPr>
+          <a:xfrm>
+            <a:off x="5852160" y="3399282"/>
+            <a:ext cx="5879592" cy="1662385"/>
+          </a:xfrm>
+          <a:prstGeom prst="rect">
+            <a:avLst/>
+          </a:prstGeom>
+          <a:ln w="9525">
+            <a:solidFill>
+              <a:srgbClr val="C9D3E3"/>
+            </a:solidFill>
+          </a:ln>
+        </p:spPr>
+      </p:pic>
+      <p:sp>
+        <p:nvSpPr>
+          <p:cNvPr id="13" name="TextBox 12"/>
+          <p:cNvSpPr txBox="1"/>
+          <p:nvPr/>
+        </p:nvSpPr>
+        <p:spPr>
+          <a:xfrm>
+            <a:off x="5806440" y="5153107"/>
+            <a:ext cx="5879592" cy="274320"/>
+          </a:xfrm>
+          <a:prstGeom prst="rect">
+            <a:avLst/>
+          </a:prstGeom>
+          <a:noFill/>
+        </p:spPr>
+        <p:txBody>
+          <a:bodyPr wrap="square">
+            <a:spAutoFit/>
+          </a:bodyPr>
+          <a:lstStyle/>
+          <a:p>
+            <a:pPr marL="0" indent="0">
+              <a:buNone/>
+            </a:pPr>
+            <a:r>
+              <a:rPr sz="1100" b="1">
+                <a:solidFill>
+                  <a:srgbClr val="555555"/>
+                </a:solidFill>
+                <a:latin typeface="Arial"/>
+              </a:rPr>
+              <a:t>WHO · each host removed and the forecast recomputed</a:t>
+            </a:r>
+          </a:p>
+        </p:txBody>
+      </p:sp>
+      <p:pic>
+        <p:nvPicPr>
+          <p:cNvPr id="14" name="Picture 13" descr="panel_flagged.png"/>
+          <p:cNvPicPr>
+            <a:picLocks noChangeAspect="1"/>
+          </p:cNvPicPr>
+          <p:nvPr/>
+        </p:nvPicPr>
+        <p:blipFill>
+          <a:blip r:embed="rId5"/>
+          <a:stretch>
+            <a:fillRect/>
+          </a:stretch>
+        </p:blipFill>
+        <p:spPr>
+          <a:xfrm>
+            <a:off x="5852160" y="5409139"/>
+            <a:ext cx="5879592" cy="927436"/>
+          </a:xfrm>
+          <a:prstGeom prst="rect">
+            <a:avLst/>
+          </a:prstGeom>
+          <a:ln w="9525">
+            <a:solidFill>
+              <a:srgbClr val="C9D3E3"/>
+            </a:solidFill>
+          </a:ln>
+        </p:spPr>
+      </p:pic>
     </p:spTree>
   </p:cSld>
   <p:clrMapOvr>
@@ -3684,14 +4882,6 @@
 <file path=ppt/slides/slide4.xml><?xml version="1.0" encoding="utf-8"?>
 <p:sld xmlns:a="http://schemas.openxmlformats.org/drawingml/2006/main" xmlns:p="http://schemas.openxmlformats.org/presentationml/2006/main" xmlns:r="http://schemas.openxmlformats.org/officeDocument/2006/relationships">
   <p:cSld>
-    <p:bg>
-      <p:bgPr>
-        <a:solidFill>
-          <a:srgbClr val="0E1116"/>
-        </a:solidFill>
-        <a:effectLst/>
-      </p:bgPr>
-    </p:bg>
     <p:spTree>
       <p:nvGrpSpPr>
         <p:cNvPr id="1" name=""/>
@@ -3699,16 +4889,40 @@
         <p:nvPr/>
       </p:nvGrpSpPr>
       <p:grpSpPr/>
-      <p:sp>
-        <p:nvSpPr>
-          <p:cNvPr id="2" name="TextBox 1"/>
+      <p:pic>
+        <p:nvPicPr>
+          <p:cNvPr id="2" name="Picture 1" descr="logo_brown.png"/>
+          <p:cNvPicPr>
+            <a:picLocks noChangeAspect="1"/>
+          </p:cNvPicPr>
+          <p:nvPr/>
+        </p:nvPicPr>
+        <p:blipFill>
+          <a:blip r:embed="rId2"/>
+          <a:stretch>
+            <a:fillRect/>
+          </a:stretch>
+        </p:blipFill>
+        <p:spPr>
+          <a:xfrm>
+            <a:off x="457200" y="329184"/>
+            <a:ext cx="537496" cy="603504"/>
+          </a:xfrm>
+          <a:prstGeom prst="rect">
+            <a:avLst/>
+          </a:prstGeom>
+        </p:spPr>
+      </p:pic>
+      <p:sp>
+        <p:nvSpPr>
+          <p:cNvPr id="3" name="TextBox 2"/>
           <p:cNvSpPr txBox="1"/>
           <p:nvPr/>
         </p:nvSpPr>
         <p:spPr>
           <a:xfrm>
-            <a:off x="548640" y="320040"/>
-            <a:ext cx="11064240" cy="822960"/>
+            <a:off x="1097280" y="237744"/>
+            <a:ext cx="10698480" cy="960120"/>
           </a:xfrm>
           <a:prstGeom prst="rect">
             <a:avLst/>
@@ -3716,844 +4930,97 @@
           <a:noFill/>
         </p:spPr>
         <p:txBody>
-          <a:bodyPr wrap="none">
+          <a:bodyPr wrap="square">
             <a:spAutoFit/>
           </a:bodyPr>
           <a:lstStyle/>
           <a:p>
-            <a:r>
-              <a:rPr sz="3000" b="1">
-                <a:solidFill>
-                  <a:srgbClr val="E6EDF3"/>
-                </a:solidFill>
-              </a:rPr>
-              <a:t>Results: seven datasets, test data unseen in training</a:t>
-            </a:r>
-          </a:p>
-          <a:p>
-            <a:r>
-              <a:rPr sz="1400">
-                <a:solidFill>
-                  <a:srgbClr val="2DD4BF"/>
-                </a:solidFill>
-              </a:rPr>
-              <a:t>AUROC world model / logistic regression on the same features; thresholds calibrated on validation only</a:t>
-            </a:r>
-          </a:p>
-        </p:txBody>
-      </p:sp>
-      <p:graphicFrame>
-        <p:nvGraphicFramePr>
-          <p:cNvPr id="3" name="Table 2"/>
-          <p:cNvGraphicFramePr>
-            <a:graphicFrameLocks noGrp="1"/>
-          </p:cNvGraphicFramePr>
+            <a:pPr marL="0" indent="0">
+              <a:buNone/>
+            </a:pPr>
+            <a:r>
+              <a:rPr sz="2800" b="1">
+                <a:solidFill>
+                  <a:srgbClr val="202020"/>
+                </a:solidFill>
+                <a:latin typeface="Arial"/>
+              </a:rPr>
+              <a:t>Results: tested only on traffic the model never saw</a:t>
+            </a:r>
+          </a:p>
+          <a:p>
+            <a:pPr marL="0" indent="0">
+              <a:spcBef>
+                <a:spcPts val="200"/>
+              </a:spcBef>
+              <a:buNone/>
+            </a:pPr>
+            <a:r>
+              <a:rPr sz="1350" b="0">
+                <a:solidFill>
+                  <a:srgbClr val="1F4E9A"/>
+                </a:solidFill>
+                <a:latin typeface="Arial"/>
+              </a:rPr>
+              <a:t>AUROC, world model vs logistic regression on the same features · thresholds calibrated on validation only</a:t>
+            </a:r>
+          </a:p>
+        </p:txBody>
+      </p:sp>
+      <p:sp>
+        <p:nvSpPr>
+          <p:cNvPr id="4" name="Rectangle 3"/>
+          <p:cNvSpPr/>
           <p:nvPr/>
-        </p:nvGraphicFramePr>
-        <p:xfrm>
-          <a:off x="548640" y="1554480"/>
-          <a:ext cx="7132320" cy="4023360"/>
-        </p:xfrm>
-        <a:graphic>
-          <a:graphicData uri="http://schemas.openxmlformats.org/drawingml/2006/table">
-            <a:tbl>
-              <a:tblPr firstRow="1" bandRow="1">
-                <a:tableStyleId>{5C22544A-7EE6-4342-B048-85BDC9FD1C3A}</a:tableStyleId>
-              </a:tblPr>
-              <a:tblGrid>
-                <a:gridCol w="2468880"/>
-                <a:gridCol w="1554480"/>
-                <a:gridCol w="1554480"/>
-                <a:gridCol w="1554480"/>
-              </a:tblGrid>
-              <a:tr h="447040">
-                <a:tc>
-                  <a:txBody>
-                    <a:bodyPr/>
-                    <a:lstStyle/>
-                    <a:p>
-                      <a:r>
-                        <a:rPr sz="1100" b="1">
-                          <a:solidFill>
-                            <a:srgbClr val="E6EDF3"/>
-                          </a:solidFill>
-                        </a:rPr>
-                        <a:t>Dataset (unseen test data)</a:t>
-                      </a:r>
-                    </a:p>
-                  </a:txBody>
-                  <a:tcPr>
-                    <a:solidFill>
-                      <a:srgbClr val="0F766E"/>
-                    </a:solidFill>
-                  </a:tcPr>
-                </a:tc>
-                <a:tc>
-                  <a:txBody>
-                    <a:bodyPr/>
-                    <a:lstStyle/>
-                    <a:p>
-                      <a:r>
-                        <a:rPr sz="1100" b="1">
-                          <a:solidFill>
-                            <a:srgbClr val="E6EDF3"/>
-                          </a:solidFill>
-                        </a:rPr>
-                        <a:t>Forecast WM / LR</a:t>
-                      </a:r>
-                    </a:p>
-                  </a:txBody>
-                  <a:tcPr>
-                    <a:solidFill>
-                      <a:srgbClr val="0F766E"/>
-                    </a:solidFill>
-                  </a:tcPr>
-                </a:tc>
-                <a:tc>
-                  <a:txBody>
-                    <a:bodyPr/>
-                    <a:lstStyle/>
-                    <a:p>
-                      <a:r>
-                        <a:rPr sz="1100" b="1">
-                          <a:solidFill>
-                            <a:srgbClr val="E6EDF3"/>
-                          </a:solidFill>
-                        </a:rPr>
-                        <a:t>Early warning WM / LR</a:t>
-                      </a:r>
-                    </a:p>
-                  </a:txBody>
-                  <a:tcPr>
-                    <a:solidFill>
-                      <a:srgbClr val="0F766E"/>
-                    </a:solidFill>
-                  </a:tcPr>
-                </a:tc>
-                <a:tc>
-                  <a:txBody>
-                    <a:bodyPr/>
-                    <a:lstStyle/>
-                    <a:p>
-                      <a:r>
-                        <a:rPr sz="1100" b="1">
-                          <a:solidFill>
-                            <a:srgbClr val="E6EDF3"/>
-                          </a:solidFill>
-                        </a:rPr>
-                        <a:t>Detection WM / LR</a:t>
-                      </a:r>
-                    </a:p>
-                  </a:txBody>
-                  <a:tcPr>
-                    <a:solidFill>
-                      <a:srgbClr val="0F766E"/>
-                    </a:solidFill>
-                  </a:tcPr>
-                </a:tc>
-              </a:tr>
-              <a:tr h="447040">
-                <a:tc>
-                  <a:txBody>
-                    <a:bodyPr/>
-                    <a:lstStyle/>
-                    <a:p>
-                      <a:r>
-                        <a:rPr sz="1200" b="0">
-                          <a:solidFill>
-                            <a:srgbClr val="E6EDF3"/>
-                          </a:solidFill>
-                        </a:rPr>
-                        <a:t>CTU-13</a:t>
-                      </a:r>
-                    </a:p>
-                  </a:txBody>
-                  <a:tcPr>
-                    <a:solidFill>
-                      <a:srgbClr val="1C222B"/>
-                    </a:solidFill>
-                  </a:tcPr>
-                </a:tc>
-                <a:tc>
-                  <a:txBody>
-                    <a:bodyPr/>
-                    <a:lstStyle/>
-                    <a:p>
-                      <a:r>
-                        <a:rPr sz="1200" b="0">
-                          <a:solidFill>
-                            <a:srgbClr val="E6EDF3"/>
-                          </a:solidFill>
-                        </a:rPr>
-                        <a:t>0.83 / 0.60</a:t>
-                      </a:r>
-                    </a:p>
-                  </a:txBody>
-                  <a:tcPr>
-                    <a:solidFill>
-                      <a:srgbClr val="1C222B"/>
-                    </a:solidFill>
-                  </a:tcPr>
-                </a:tc>
-                <a:tc>
-                  <a:txBody>
-                    <a:bodyPr/>
-                    <a:lstStyle/>
-                    <a:p>
-                      <a:r>
-                        <a:rPr sz="1200" b="0">
-                          <a:solidFill>
-                            <a:srgbClr val="E6EDF3"/>
-                          </a:solidFill>
-                        </a:rPr>
-                        <a:t>0.82 / 0.48</a:t>
-                      </a:r>
-                    </a:p>
-                  </a:txBody>
-                  <a:tcPr>
-                    <a:solidFill>
-                      <a:srgbClr val="1C222B"/>
-                    </a:solidFill>
-                  </a:tcPr>
-                </a:tc>
-                <a:tc>
-                  <a:txBody>
-                    <a:bodyPr/>
-                    <a:lstStyle/>
-                    <a:p>
-                      <a:r>
-                        <a:rPr sz="1200" b="0">
-                          <a:solidFill>
-                            <a:srgbClr val="E6EDF3"/>
-                          </a:solidFill>
-                        </a:rPr>
-                        <a:t>0.89 / 0.74</a:t>
-                      </a:r>
-                    </a:p>
-                  </a:txBody>
-                  <a:tcPr>
-                    <a:solidFill>
-                      <a:srgbClr val="1C222B"/>
-                    </a:solidFill>
-                  </a:tcPr>
-                </a:tc>
-              </a:tr>
-              <a:tr h="447040">
-                <a:tc>
-                  <a:txBody>
-                    <a:bodyPr/>
-                    <a:lstStyle/>
-                    <a:p>
-                      <a:r>
-                        <a:rPr sz="1200" b="0">
-                          <a:solidFill>
-                            <a:srgbClr val="E6EDF3"/>
-                          </a:solidFill>
-                        </a:rPr>
-                        <a:t>CIC-IDS2017</a:t>
-                      </a:r>
-                    </a:p>
-                  </a:txBody>
-                  <a:tcPr>
-                    <a:solidFill>
-                      <a:srgbClr val="1C222B"/>
-                    </a:solidFill>
-                  </a:tcPr>
-                </a:tc>
-                <a:tc>
-                  <a:txBody>
-                    <a:bodyPr/>
-                    <a:lstStyle/>
-                    <a:p>
-                      <a:r>
-                        <a:rPr sz="1200" b="0">
-                          <a:solidFill>
-                            <a:srgbClr val="E6EDF3"/>
-                          </a:solidFill>
-                        </a:rPr>
-                        <a:t>0.56 / 0.56</a:t>
-                      </a:r>
-                    </a:p>
-                  </a:txBody>
-                  <a:tcPr>
-                    <a:solidFill>
-                      <a:srgbClr val="1C222B"/>
-                    </a:solidFill>
-                  </a:tcPr>
-                </a:tc>
-                <a:tc>
-                  <a:txBody>
-                    <a:bodyPr/>
-                    <a:lstStyle/>
-                    <a:p>
-                      <a:r>
-                        <a:rPr sz="1200" b="0">
-                          <a:solidFill>
-                            <a:srgbClr val="E6EDF3"/>
-                          </a:solidFill>
-                        </a:rPr>
-                        <a:t>0.47 / 0.47</a:t>
-                      </a:r>
-                    </a:p>
-                  </a:txBody>
-                  <a:tcPr>
-                    <a:solidFill>
-                      <a:srgbClr val="1C222B"/>
-                    </a:solidFill>
-                  </a:tcPr>
-                </a:tc>
-                <a:tc>
-                  <a:txBody>
-                    <a:bodyPr/>
-                    <a:lstStyle/>
-                    <a:p>
-                      <a:r>
-                        <a:rPr sz="1200" b="0">
-                          <a:solidFill>
-                            <a:srgbClr val="E6EDF3"/>
-                          </a:solidFill>
-                        </a:rPr>
-                        <a:t>0.65 / 0.65</a:t>
-                      </a:r>
-                    </a:p>
-                  </a:txBody>
-                  <a:tcPr>
-                    <a:solidFill>
-                      <a:srgbClr val="1C222B"/>
-                    </a:solidFill>
-                  </a:tcPr>
-                </a:tc>
-              </a:tr>
-              <a:tr h="447040">
-                <a:tc>
-                  <a:txBody>
-                    <a:bodyPr/>
-                    <a:lstStyle/>
-                    <a:p>
-                      <a:r>
-                        <a:rPr sz="1200" b="0">
-                          <a:solidFill>
-                            <a:srgbClr val="E6EDF3"/>
-                          </a:solidFill>
-                        </a:rPr>
-                        <a:t>CSE-CIC-IDS2018</a:t>
-                      </a:r>
-                    </a:p>
-                  </a:txBody>
-                  <a:tcPr>
-                    <a:solidFill>
-                      <a:srgbClr val="1C222B"/>
-                    </a:solidFill>
-                  </a:tcPr>
-                </a:tc>
-                <a:tc>
-                  <a:txBody>
-                    <a:bodyPr/>
-                    <a:lstStyle/>
-                    <a:p>
-                      <a:r>
-                        <a:rPr sz="1200" b="0">
-                          <a:solidFill>
-                            <a:srgbClr val="E6EDF3"/>
-                          </a:solidFill>
-                        </a:rPr>
-                        <a:t>0.83 / 0.60</a:t>
-                      </a:r>
-                    </a:p>
-                  </a:txBody>
-                  <a:tcPr>
-                    <a:solidFill>
-                      <a:srgbClr val="1C222B"/>
-                    </a:solidFill>
-                  </a:tcPr>
-                </a:tc>
-                <a:tc>
-                  <a:txBody>
-                    <a:bodyPr/>
-                    <a:lstStyle/>
-                    <a:p>
-                      <a:r>
-                        <a:rPr sz="1200" b="0">
-                          <a:solidFill>
-                            <a:srgbClr val="E6EDF3"/>
-                          </a:solidFill>
-                        </a:rPr>
-                        <a:t>0.57 / 0.55</a:t>
-                      </a:r>
-                    </a:p>
-                  </a:txBody>
-                  <a:tcPr>
-                    <a:solidFill>
-                      <a:srgbClr val="1C222B"/>
-                    </a:solidFill>
-                  </a:tcPr>
-                </a:tc>
-                <a:tc>
-                  <a:txBody>
-                    <a:bodyPr/>
-                    <a:lstStyle/>
-                    <a:p>
-                      <a:r>
-                        <a:rPr sz="1200" b="0">
-                          <a:solidFill>
-                            <a:srgbClr val="E6EDF3"/>
-                          </a:solidFill>
-                        </a:rPr>
-                        <a:t>0.83 / 0.62</a:t>
-                      </a:r>
-                    </a:p>
-                  </a:txBody>
-                  <a:tcPr>
-                    <a:solidFill>
-                      <a:srgbClr val="1C222B"/>
-                    </a:solidFill>
-                  </a:tcPr>
-                </a:tc>
-              </a:tr>
-              <a:tr h="447040">
-                <a:tc>
-                  <a:txBody>
-                    <a:bodyPr/>
-                    <a:lstStyle/>
-                    <a:p>
-                      <a:r>
-                        <a:rPr sz="1200" b="0">
-                          <a:solidFill>
-                            <a:srgbClr val="E6EDF3"/>
-                          </a:solidFill>
-                        </a:rPr>
-                        <a:t>UNSW-NB15</a:t>
-                      </a:r>
-                    </a:p>
-                  </a:txBody>
-                  <a:tcPr>
-                    <a:solidFill>
-                      <a:srgbClr val="1C222B"/>
-                    </a:solidFill>
-                  </a:tcPr>
-                </a:tc>
-                <a:tc>
-                  <a:txBody>
-                    <a:bodyPr/>
-                    <a:lstStyle/>
-                    <a:p>
-                      <a:r>
-                        <a:rPr sz="1200" b="0">
-                          <a:solidFill>
-                            <a:srgbClr val="E6EDF3"/>
-                          </a:solidFill>
-                        </a:rPr>
-                        <a:t>0.95 / 0.99</a:t>
-                      </a:r>
-                    </a:p>
-                  </a:txBody>
-                  <a:tcPr>
-                    <a:solidFill>
-                      <a:srgbClr val="1C222B"/>
-                    </a:solidFill>
-                  </a:tcPr>
-                </a:tc>
-                <a:tc>
-                  <a:txBody>
-                    <a:bodyPr/>
-                    <a:lstStyle/>
-                    <a:p>
-                      <a:r>
-                        <a:rPr sz="1200" b="0">
-                          <a:solidFill>
-                            <a:srgbClr val="E6EDF3"/>
-                          </a:solidFill>
-                        </a:rPr>
-                        <a:t>0.63 / 0.71</a:t>
-                      </a:r>
-                    </a:p>
-                  </a:txBody>
-                  <a:tcPr>
-                    <a:solidFill>
-                      <a:srgbClr val="1C222B"/>
-                    </a:solidFill>
-                  </a:tcPr>
-                </a:tc>
-                <a:tc>
-                  <a:txBody>
-                    <a:bodyPr/>
-                    <a:lstStyle/>
-                    <a:p>
-                      <a:r>
-                        <a:rPr sz="1200" b="0">
-                          <a:solidFill>
-                            <a:srgbClr val="E6EDF3"/>
-                          </a:solidFill>
-                        </a:rPr>
-                        <a:t>1.00 / 0.95</a:t>
-                      </a:r>
-                    </a:p>
-                  </a:txBody>
-                  <a:tcPr>
-                    <a:solidFill>
-                      <a:srgbClr val="1C222B"/>
-                    </a:solidFill>
-                  </a:tcPr>
-                </a:tc>
-              </a:tr>
-              <a:tr h="447040">
-                <a:tc>
-                  <a:txBody>
-                    <a:bodyPr/>
-                    <a:lstStyle/>
-                    <a:p>
-                      <a:r>
-                        <a:rPr sz="1200" b="0">
-                          <a:solidFill>
-                            <a:srgbClr val="E6EDF3"/>
-                          </a:solidFill>
-                        </a:rPr>
-                        <a:t>LANL cyber1</a:t>
-                      </a:r>
-                    </a:p>
-                  </a:txBody>
-                  <a:tcPr>
-                    <a:solidFill>
-                      <a:srgbClr val="1C222B"/>
-                    </a:solidFill>
-                  </a:tcPr>
-                </a:tc>
-                <a:tc>
-                  <a:txBody>
-                    <a:bodyPr/>
-                    <a:lstStyle/>
-                    <a:p>
-                      <a:r>
-                        <a:rPr sz="1200" b="0">
-                          <a:solidFill>
-                            <a:srgbClr val="E6EDF3"/>
-                          </a:solidFill>
-                        </a:rPr>
-                        <a:t>0.37 / 0.56</a:t>
-                      </a:r>
-                    </a:p>
-                  </a:txBody>
-                  <a:tcPr>
-                    <a:solidFill>
-                      <a:srgbClr val="1C222B"/>
-                    </a:solidFill>
-                  </a:tcPr>
-                </a:tc>
-                <a:tc>
-                  <a:txBody>
-                    <a:bodyPr/>
-                    <a:lstStyle/>
-                    <a:p>
-                      <a:r>
-                        <a:rPr sz="1200" b="0">
-                          <a:solidFill>
-                            <a:srgbClr val="E6EDF3"/>
-                          </a:solidFill>
-                        </a:rPr>
-                        <a:t>0.34 / 0.57</a:t>
-                      </a:r>
-                    </a:p>
-                  </a:txBody>
-                  <a:tcPr>
-                    <a:solidFill>
-                      <a:srgbClr val="1C222B"/>
-                    </a:solidFill>
-                  </a:tcPr>
-                </a:tc>
-                <a:tc>
-                  <a:txBody>
-                    <a:bodyPr/>
-                    <a:lstStyle/>
-                    <a:p>
-                      <a:r>
-                        <a:rPr sz="1200" b="0">
-                          <a:solidFill>
-                            <a:srgbClr val="E6EDF3"/>
-                          </a:solidFill>
-                        </a:rPr>
-                        <a:t>0.40 / 0.55</a:t>
-                      </a:r>
-                    </a:p>
-                  </a:txBody>
-                  <a:tcPr>
-                    <a:solidFill>
-                      <a:srgbClr val="1C222B"/>
-                    </a:solidFill>
-                  </a:tcPr>
-                </a:tc>
-              </a:tr>
-              <a:tr h="447040">
-                <a:tc>
-                  <a:txBody>
-                    <a:bodyPr/>
-                    <a:lstStyle/>
-                    <a:p>
-                      <a:r>
-                        <a:rPr sz="1200" b="0">
-                          <a:solidFill>
-                            <a:srgbClr val="E6EDF3"/>
-                          </a:solidFill>
-                        </a:rPr>
-                        <a:t>DARPA 1999</a:t>
-                      </a:r>
-                    </a:p>
-                  </a:txBody>
-                  <a:tcPr>
-                    <a:solidFill>
-                      <a:srgbClr val="1C222B"/>
-                    </a:solidFill>
-                  </a:tcPr>
-                </a:tc>
-                <a:tc>
-                  <a:txBody>
-                    <a:bodyPr/>
-                    <a:lstStyle/>
-                    <a:p>
-                      <a:r>
-                        <a:rPr sz="1200" b="0">
-                          <a:solidFill>
-                            <a:srgbClr val="E6EDF3"/>
-                          </a:solidFill>
-                        </a:rPr>
-                        <a:t>0.63 / 0.69</a:t>
-                      </a:r>
-                    </a:p>
-                  </a:txBody>
-                  <a:tcPr>
-                    <a:solidFill>
-                      <a:srgbClr val="1C222B"/>
-                    </a:solidFill>
-                  </a:tcPr>
-                </a:tc>
-                <a:tc>
-                  <a:txBody>
-                    <a:bodyPr/>
-                    <a:lstStyle/>
-                    <a:p>
-                      <a:r>
-                        <a:rPr sz="1200" b="0">
-                          <a:solidFill>
-                            <a:srgbClr val="E6EDF3"/>
-                          </a:solidFill>
-                        </a:rPr>
-                        <a:t>0.60 / 0.61</a:t>
-                      </a:r>
-                    </a:p>
-                  </a:txBody>
-                  <a:tcPr>
-                    <a:solidFill>
-                      <a:srgbClr val="1C222B"/>
-                    </a:solidFill>
-                  </a:tcPr>
-                </a:tc>
-                <a:tc>
-                  <a:txBody>
-                    <a:bodyPr/>
-                    <a:lstStyle/>
-                    <a:p>
-                      <a:r>
-                        <a:rPr sz="1200" b="0">
-                          <a:solidFill>
-                            <a:srgbClr val="E6EDF3"/>
-                          </a:solidFill>
-                        </a:rPr>
-                        <a:t>0.69 / 0.81</a:t>
-                      </a:r>
-                    </a:p>
-                  </a:txBody>
-                  <a:tcPr>
-                    <a:solidFill>
-                      <a:srgbClr val="1C222B"/>
-                    </a:solidFill>
-                  </a:tcPr>
-                </a:tc>
-              </a:tr>
-              <a:tr h="447040">
-                <a:tc>
-                  <a:txBody>
-                    <a:bodyPr/>
-                    <a:lstStyle/>
-                    <a:p>
-                      <a:r>
-                        <a:rPr sz="1200" b="0">
-                          <a:solidFill>
-                            <a:srgbClr val="E6EDF3"/>
-                          </a:solidFill>
-                        </a:rPr>
-                        <a:t>CICIoT2023</a:t>
-                      </a:r>
-                    </a:p>
-                  </a:txBody>
-                  <a:tcPr>
-                    <a:solidFill>
-                      <a:srgbClr val="1C222B"/>
-                    </a:solidFill>
-                  </a:tcPr>
-                </a:tc>
-                <a:tc>
-                  <a:txBody>
-                    <a:bodyPr/>
-                    <a:lstStyle/>
-                    <a:p>
-                      <a:r>
-                        <a:rPr sz="1200" b="0">
-                          <a:solidFill>
-                            <a:srgbClr val="E6EDF3"/>
-                          </a:solidFill>
-                        </a:rPr>
-                        <a:t>n/a</a:t>
-                      </a:r>
-                    </a:p>
-                  </a:txBody>
-                  <a:tcPr>
-                    <a:solidFill>
-                      <a:srgbClr val="1C222B"/>
-                    </a:solidFill>
-                  </a:tcPr>
-                </a:tc>
-                <a:tc>
-                  <a:txBody>
-                    <a:bodyPr/>
-                    <a:lstStyle/>
-                    <a:p>
-                      <a:r>
-                        <a:rPr sz="1200" b="0">
-                          <a:solidFill>
-                            <a:srgbClr val="E6EDF3"/>
-                          </a:solidFill>
-                        </a:rPr>
-                        <a:t>n/a</a:t>
-                      </a:r>
-                    </a:p>
-                  </a:txBody>
-                  <a:tcPr>
-                    <a:solidFill>
-                      <a:srgbClr val="1C222B"/>
-                    </a:solidFill>
-                  </a:tcPr>
-                </a:tc>
-                <a:tc>
-                  <a:txBody>
-                    <a:bodyPr/>
-                    <a:lstStyle/>
-                    <a:p>
-                      <a:r>
-                        <a:rPr sz="1200" b="0">
-                          <a:solidFill>
-                            <a:srgbClr val="E6EDF3"/>
-                          </a:solidFill>
-                        </a:rPr>
-                        <a:t>0.99 / 0.76</a:t>
-                      </a:r>
-                    </a:p>
-                  </a:txBody>
-                  <a:tcPr>
-                    <a:solidFill>
-                      <a:srgbClr val="1C222B"/>
-                    </a:solidFill>
-                  </a:tcPr>
-                </a:tc>
-              </a:tr>
-              <a:tr h="447040">
-                <a:tc>
-                  <a:txBody>
-                    <a:bodyPr/>
-                    <a:lstStyle/>
-                    <a:p>
-                      <a:r>
-                        <a:rPr sz="1200" b="1">
-                          <a:solidFill>
-                            <a:srgbClr val="E6EDF3"/>
-                          </a:solidFill>
-                        </a:rPr>
-                        <a:t>Macro average (temporal)</a:t>
-                      </a:r>
-                    </a:p>
-                  </a:txBody>
-                  <a:tcPr>
-                    <a:solidFill>
-                      <a:srgbClr val="1C222B"/>
-                    </a:solidFill>
-                  </a:tcPr>
-                </a:tc>
-                <a:tc>
-                  <a:txBody>
-                    <a:bodyPr/>
-                    <a:lstStyle/>
-                    <a:p>
-                      <a:r>
-                        <a:rPr sz="1200" b="1">
-                          <a:solidFill>
-                            <a:srgbClr val="E6EDF3"/>
-                          </a:solidFill>
-                        </a:rPr>
-                        <a:t>0.70 / 0.67</a:t>
-                      </a:r>
-                    </a:p>
-                  </a:txBody>
-                  <a:tcPr>
-                    <a:solidFill>
-                      <a:srgbClr val="1C222B"/>
-                    </a:solidFill>
-                  </a:tcPr>
-                </a:tc>
-                <a:tc>
-                  <a:txBody>
-                    <a:bodyPr/>
-                    <a:lstStyle/>
-                    <a:p>
-                      <a:r>
-                        <a:rPr sz="1200" b="1">
-                          <a:solidFill>
-                            <a:srgbClr val="E6EDF3"/>
-                          </a:solidFill>
-                        </a:rPr>
-                        <a:t>0.57 / 0.57</a:t>
-                      </a:r>
-                    </a:p>
-                  </a:txBody>
-                  <a:tcPr>
-                    <a:solidFill>
-                      <a:srgbClr val="1C222B"/>
-                    </a:solidFill>
-                  </a:tcPr>
-                </a:tc>
-                <a:tc>
-                  <a:txBody>
-                    <a:bodyPr/>
-                    <a:lstStyle/>
-                    <a:p>
-                      <a:r>
-                        <a:rPr sz="1200" b="1">
-                          <a:solidFill>
-                            <a:srgbClr val="E6EDF3"/>
-                          </a:solidFill>
-                        </a:rPr>
-                        <a:t>0.74 / 0.72</a:t>
-                      </a:r>
-                    </a:p>
-                  </a:txBody>
-                  <a:tcPr>
-                    <a:solidFill>
-                      <a:srgbClr val="1C222B"/>
-                    </a:solidFill>
-                  </a:tcPr>
-                </a:tc>
-              </a:tr>
-            </a:tbl>
-          </a:graphicData>
-        </a:graphic>
-      </p:graphicFrame>
-      <p:sp>
-        <p:nvSpPr>
-          <p:cNvPr id="4" name="TextBox 3"/>
+        </p:nvSpPr>
+        <p:spPr>
+          <a:xfrm>
+            <a:off x="457200" y="6391656"/>
+            <a:ext cx="11274552" cy="10972"/>
+          </a:xfrm>
+          <a:prstGeom prst="rect">
+            <a:avLst/>
+          </a:prstGeom>
+          <a:solidFill>
+            <a:srgbClr val="C9D3E3"/>
+          </a:solidFill>
+          <a:ln>
+            <a:noFill/>
+          </a:ln>
+          <a:effectLst/>
+        </p:spPr>
+        <p:style>
+          <a:lnRef idx="1">
+            <a:schemeClr val="accent1"/>
+          </a:lnRef>
+          <a:fillRef idx="3">
+            <a:schemeClr val="accent1"/>
+          </a:fillRef>
+          <a:effectRef idx="2">
+            <a:schemeClr val="accent1"/>
+          </a:effectRef>
+          <a:fontRef idx="minor">
+            <a:schemeClr val="lt1"/>
+          </a:fontRef>
+        </p:style>
+        <p:txBody>
+          <a:bodyPr rtlCol="0" anchor="ctr"/>
+          <a:lstStyle/>
+          <a:p>
+            <a:pPr algn="ctr"/>
+          </a:p>
+        </p:txBody>
+      </p:sp>
+      <p:sp>
+        <p:nvSpPr>
+          <p:cNvPr id="5" name="TextBox 4"/>
           <p:cNvSpPr txBox="1"/>
           <p:nvPr/>
         </p:nvSpPr>
         <p:spPr>
           <a:xfrm>
-            <a:off x="7955279" y="1554480"/>
-            <a:ext cx="3931920" cy="4846320"/>
+            <a:off x="457200" y="6419088"/>
+            <a:ext cx="9144000" cy="274320"/>
           </a:xfrm>
           <a:prstGeom prst="rect">
             <a:avLst/>
@@ -4566,95 +5033,311 @@
           </a:bodyPr>
           <a:lstStyle/>
           <a:p>
-            <a:pPr>
-              <a:spcAft>
+            <a:pPr marL="0" indent="0">
+              <a:buNone/>
+            </a:pPr>
+            <a:r>
+              <a:rPr sz="900" b="0">
+                <a:solidFill>
+                  <a:srgbClr val="555555"/>
+                </a:solidFill>
+                <a:latin typeface="Arial"/>
+              </a:rPr>
+              <a:t>VIGHNAX · SIH 2026 · PS SIH26153 (NTRO) · Team ID 127364</a:t>
+            </a:r>
+          </a:p>
+        </p:txBody>
+      </p:sp>
+      <p:sp>
+        <p:nvSpPr>
+          <p:cNvPr id="6" name="TextBox 5"/>
+          <p:cNvSpPr txBox="1"/>
+          <p:nvPr/>
+        </p:nvSpPr>
+        <p:spPr>
+          <a:xfrm>
+            <a:off x="10789920" y="6419088"/>
+            <a:ext cx="941832" cy="274320"/>
+          </a:xfrm>
+          <a:prstGeom prst="rect">
+            <a:avLst/>
+          </a:prstGeom>
+          <a:noFill/>
+        </p:spPr>
+        <p:txBody>
+          <a:bodyPr wrap="square">
+            <a:spAutoFit/>
+          </a:bodyPr>
+          <a:lstStyle/>
+          <a:p>
+            <a:pPr marL="0" indent="0" algn="r">
+              <a:buNone/>
+            </a:pPr>
+            <a:r>
+              <a:rPr sz="900" b="0">
+                <a:solidFill>
+                  <a:srgbClr val="555555"/>
+                </a:solidFill>
+                <a:latin typeface="Arial"/>
+              </a:rPr>
+              <a:t>4 / 5</a:t>
+            </a:r>
+          </a:p>
+        </p:txBody>
+      </p:sp>
+      <p:pic>
+        <p:nvPicPr>
+          <p:cNvPr id="7" name="Picture 6" descr="results3.png"/>
+          <p:cNvPicPr>
+            <a:picLocks noChangeAspect="1"/>
+          </p:cNvPicPr>
+          <p:nvPr/>
+        </p:nvPicPr>
+        <p:blipFill>
+          <a:blip r:embed="rId3"/>
+          <a:stretch>
+            <a:fillRect/>
+          </a:stretch>
+        </p:blipFill>
+        <p:spPr>
+          <a:xfrm>
+            <a:off x="411480" y="1325880"/>
+            <a:ext cx="7955279" cy="4160519"/>
+          </a:xfrm>
+          <a:prstGeom prst="rect">
+            <a:avLst/>
+          </a:prstGeom>
+        </p:spPr>
+      </p:pic>
+      <p:sp>
+        <p:nvSpPr>
+          <p:cNvPr id="8" name="TextBox 7"/>
+          <p:cNvSpPr txBox="1"/>
+          <p:nvPr/>
+        </p:nvSpPr>
+        <p:spPr>
+          <a:xfrm>
+            <a:off x="457200" y="5532120"/>
+            <a:ext cx="7863840" cy="731520"/>
+          </a:xfrm>
+          <a:prstGeom prst="rect">
+            <a:avLst/>
+          </a:prstGeom>
+          <a:noFill/>
+        </p:spPr>
+        <p:txBody>
+          <a:bodyPr wrap="square">
+            <a:spAutoFit/>
+          </a:bodyPr>
+          <a:lstStyle/>
+          <a:p>
+            <a:pPr marL="0" indent="0">
+              <a:buNone/>
+            </a:pPr>
+            <a:r>
+              <a:rPr sz="1000" b="0">
+                <a:solidFill>
+                  <a:srgbClr val="555555"/>
+                </a:solidFill>
+                <a:latin typeface="Arial"/>
+              </a:rPr>
+              <a:t>0.5 = chance. Early warning = forecasting from windows that are still benign. CICIoT2023 episodes are composed, so only detection is scored. *Mean over the six temporal datasets.</a:t>
+            </a:r>
+          </a:p>
+        </p:txBody>
+      </p:sp>
+      <p:sp>
+        <p:nvSpPr>
+          <p:cNvPr id="9" name="Rounded Rectangle 8"/>
+          <p:cNvSpPr/>
+          <p:nvPr/>
+        </p:nvSpPr>
+        <p:spPr>
+          <a:xfrm>
+            <a:off x="8641080" y="1417320"/>
+            <a:ext cx="3090672" cy="1417320"/>
+          </a:xfrm>
+          <a:prstGeom prst="roundRect">
+            <a:avLst>
+              <a:gd name="adj" fmla="val 7000"/>
+            </a:avLst>
+          </a:prstGeom>
+          <a:solidFill>
+            <a:srgbClr val="EEF3FA"/>
+          </a:solidFill>
+          <a:ln>
+            <a:noFill/>
+          </a:ln>
+          <a:effectLst/>
+        </p:spPr>
+        <p:style>
+          <a:lnRef idx="1">
+            <a:schemeClr val="accent1"/>
+          </a:lnRef>
+          <a:fillRef idx="3">
+            <a:schemeClr val="accent1"/>
+          </a:fillRef>
+          <a:effectRef idx="2">
+            <a:schemeClr val="accent1"/>
+          </a:effectRef>
+          <a:fontRef idx="minor">
+            <a:schemeClr val="lt1"/>
+          </a:fontRef>
+        </p:style>
+        <p:txBody>
+          <a:bodyPr rtlCol="0" anchor="ctr" wrap="square" lIns="128016" rIns="128016" tIns="64008" bIns="64008"/>
+          <a:lstStyle/>
+          <a:p>
+            <a:pPr algn="ctr" marL="0" indent="0">
+              <a:buNone/>
+            </a:pPr>
+            <a:r>
+              <a:rPr sz="2400" b="1">
+                <a:solidFill>
+                  <a:srgbClr val="1F4E9A"/>
+                </a:solidFill>
+                <a:latin typeface="Arial"/>
+              </a:rPr>
+              <a:t>54 / 201</a:t>
+            </a:r>
+          </a:p>
+          <a:p>
+            <a:pPr marL="0" indent="0" algn="ctr">
+              <a:spcBef>
+                <a:spcPts val="200"/>
+              </a:spcBef>
+              <a:buNone/>
+            </a:pPr>
+            <a:r>
+              <a:rPr sz="1050" b="0">
+                <a:solidFill>
+                  <a:srgbClr val="202020"/>
+                </a:solidFill>
+                <a:latin typeface="Arial"/>
+              </a:rPr>
+              <a:t>attack onsets forecast before they began (baseline: 17), 51–60 s ahead</a:t>
+            </a:r>
+          </a:p>
+        </p:txBody>
+      </p:sp>
+      <p:sp>
+        <p:nvSpPr>
+          <p:cNvPr id="10" name="TextBox 9"/>
+          <p:cNvSpPr txBox="1"/>
+          <p:nvPr/>
+        </p:nvSpPr>
+        <p:spPr>
+          <a:xfrm>
+            <a:off x="8595360" y="3017520"/>
+            <a:ext cx="3154680" cy="3291840"/>
+          </a:xfrm>
+          <a:prstGeom prst="rect">
+            <a:avLst/>
+          </a:prstGeom>
+          <a:noFill/>
+        </p:spPr>
+        <p:txBody>
+          <a:bodyPr wrap="square">
+            <a:spAutoFit/>
+          </a:bodyPr>
+          <a:lstStyle/>
+          <a:p>
+            <a:pPr marL="0" indent="0">
+              <a:buNone/>
+            </a:pPr>
+            <a:r>
+              <a:rPr sz="1100" b="1">
+                <a:solidFill>
+                  <a:srgbClr val="1F4E9A"/>
+                </a:solidFill>
+                <a:latin typeface="Arial"/>
+              </a:rPr>
+              <a:t>WHERE WE LEAD</a:t>
+            </a:r>
+          </a:p>
+          <a:p>
+            <a:pPr marL="0" indent="0">
+              <a:spcBef>
+                <a:spcPts val="100"/>
+              </a:spcBef>
+              <a:buNone/>
+            </a:pPr>
+            <a:r>
+              <a:rPr sz="1250" b="0">
+                <a:solidFill>
+                  <a:srgbClr val="202020"/>
+                </a:solidFill>
+                <a:latin typeface="Arial"/>
+              </a:rPr>
+              <a:t>forecasting on CTU-13 and CSE-CIC-IDS2018; detection on 4 of 7 datasets</a:t>
+            </a:r>
+          </a:p>
+          <a:p>
+            <a:pPr marL="0" indent="0">
+              <a:spcBef>
                 <a:spcPts val="800"/>
-              </a:spcAft>
-            </a:pPr>
-            <a:r>
-              <a:rPr b="1" sz="1500">
-                <a:solidFill>
-                  <a:srgbClr val="2DD4BF"/>
-                </a:solidFill>
-              </a:rPr>
-              <a:t>Forecasting:</a:t>
-            </a:r>
-            <a:r>
-              <a:rPr sz="1500">
-                <a:solidFill>
-                  <a:srgbClr val="E6EDF3"/>
-                </a:solidFill>
-              </a:rPr>
-              <a:t> ahead on 2/6 datasets; early warning ahead on 2/6.</a:t>
-            </a:r>
-          </a:p>
-          <a:p>
-            <a:pPr>
-              <a:spcAft>
+              </a:spcBef>
+              <a:buNone/>
+            </a:pPr>
+            <a:r>
+              <a:rPr sz="1100" b="1">
+                <a:solidFill>
+                  <a:srgbClr val="1F4E9A"/>
+                </a:solidFill>
+                <a:latin typeface="Arial"/>
+              </a:rPr>
+              <a:t>WHERE THE BASELINE LEADS</a:t>
+            </a:r>
+          </a:p>
+          <a:p>
+            <a:pPr marL="0" indent="0">
+              <a:spcBef>
+                <a:spcPts val="100"/>
+              </a:spcBef>
+              <a:buNone/>
+            </a:pPr>
+            <a:r>
+              <a:rPr sz="1250" b="0">
+                <a:solidFill>
+                  <a:srgbClr val="202020"/>
+                </a:solidFill>
+                <a:latin typeface="Arial"/>
+              </a:rPr>
+              <a:t>UNSW-NB15, LANL cyber1, DARPA 1999 (forecast); LANL cyber1 and DARPA 1999 (detection)</a:t>
+            </a:r>
+          </a:p>
+          <a:p>
+            <a:pPr marL="0" indent="0">
+              <a:spcBef>
                 <a:spcPts val="800"/>
-              </a:spcAft>
-            </a:pPr>
-            <a:r>
-              <a:rPr b="1" sz="1500">
-                <a:solidFill>
-                  <a:srgbClr val="2DD4BF"/>
-                </a:solidFill>
-              </a:rPr>
-              <a:t>Before onset:</a:t>
-            </a:r>
-            <a:r>
-              <a:rPr sz="1500">
-                <a:solidFill>
-                  <a:srgbClr val="E6EDF3"/>
-                </a:solidFill>
-              </a:rPr>
-              <a:t> 54/201 attacks forecast before they began (LR 17).</a:t>
-            </a:r>
-          </a:p>
-          <a:p>
-            <a:pPr>
-              <a:spcAft>
-                <a:spcPts val="800"/>
-              </a:spcAft>
-            </a:pPr>
-            <a:r>
-              <a:rPr b="1" sz="1500">
-                <a:solidFill>
-                  <a:srgbClr val="2DD4BF"/>
-                </a:solidFill>
-              </a:rPr>
-              <a:t>Honest:</a:t>
-            </a:r>
-            <a:r>
-              <a:rPr sz="1500">
-                <a:solidFill>
-                  <a:srgbClr val="E6EDF3"/>
-                </a:solidFill>
-              </a:rPr>
-              <a:t> detection: LR better on LANL cyber1, DARPA 1999.</a:t>
-            </a:r>
-          </a:p>
-          <a:p>
-            <a:pPr>
-              <a:spcAft>
-                <a:spcPts val="800"/>
-              </a:spcAft>
-            </a:pPr>
-            <a:r>
-              <a:rPr b="1" sz="1500">
-                <a:solidFill>
-                  <a:srgbClr val="2DD4BF"/>
-                </a:solidFill>
-              </a:rPr>
-              <a:t>Note:</a:t>
-            </a:r>
-            <a:r>
-              <a:rPr sz="1500">
-                <a:solidFill>
-                  <a:srgbClr val="E6EDF3"/>
-                </a:solidFill>
-              </a:rPr>
-              <a:t> CICIoT2023 episodes are composed, so detection only.</a:t>
+              </a:spcBef>
+              <a:buNone/>
+            </a:pPr>
+            <a:r>
+              <a:rPr sz="1100" b="1">
+                <a:solidFill>
+                  <a:srgbClr val="1F4E9A"/>
+                </a:solidFill>
+                <a:latin typeface="Arial"/>
+              </a:rPr>
+              <a:t>OPEN PROBLEM</a:t>
+            </a:r>
+          </a:p>
+          <a:p>
+            <a:pPr marL="0" indent="0">
+              <a:spcBef>
+                <a:spcPts val="100"/>
+              </a:spcBef>
+              <a:buNone/>
+            </a:pPr>
+            <a:r>
+              <a:rPr sz="1250" b="0">
+                <a:solidFill>
+                  <a:srgbClr val="202020"/>
+                </a:solidFill>
+                <a:latin typeface="Arial"/>
+              </a:rPr>
+              <a:t>on validation the world model leads everywhere; unseen days generalise less well</a:t>
             </a:r>
           </a:p>
         </p:txBody>
@@ -4670,14 +5353,6 @@
 <file path=ppt/slides/slide5.xml><?xml version="1.0" encoding="utf-8"?>
 <p:sld xmlns:a="http://schemas.openxmlformats.org/drawingml/2006/main" xmlns:p="http://schemas.openxmlformats.org/presentationml/2006/main" xmlns:r="http://schemas.openxmlformats.org/officeDocument/2006/relationships">
   <p:cSld>
-    <p:bg>
-      <p:bgPr>
-        <a:solidFill>
-          <a:srgbClr val="0E1116"/>
-        </a:solidFill>
-        <a:effectLst/>
-      </p:bgPr>
-    </p:bg>
     <p:spTree>
       <p:nvGrpSpPr>
         <p:cNvPr id="1" name=""/>
@@ -4685,16 +5360,40 @@
         <p:nvPr/>
       </p:nvGrpSpPr>
       <p:grpSpPr/>
-      <p:sp>
-        <p:nvSpPr>
-          <p:cNvPr id="2" name="TextBox 1"/>
+      <p:pic>
+        <p:nvPicPr>
+          <p:cNvPr id="2" name="Picture 1" descr="logo_brown.png"/>
+          <p:cNvPicPr>
+            <a:picLocks noChangeAspect="1"/>
+          </p:cNvPicPr>
+          <p:nvPr/>
+        </p:nvPicPr>
+        <p:blipFill>
+          <a:blip r:embed="rId2"/>
+          <a:stretch>
+            <a:fillRect/>
+          </a:stretch>
+        </p:blipFill>
+        <p:spPr>
+          <a:xfrm>
+            <a:off x="457200" y="329184"/>
+            <a:ext cx="537496" cy="603504"/>
+          </a:xfrm>
+          <a:prstGeom prst="rect">
+            <a:avLst/>
+          </a:prstGeom>
+        </p:spPr>
+      </p:pic>
+      <p:sp>
+        <p:nvSpPr>
+          <p:cNvPr id="3" name="TextBox 2"/>
           <p:cNvSpPr txBox="1"/>
           <p:nvPr/>
         </p:nvSpPr>
         <p:spPr>
           <a:xfrm>
-            <a:off x="548640" y="320040"/>
-            <a:ext cx="11064240" cy="822960"/>
+            <a:off x="1097280" y="237744"/>
+            <a:ext cx="10698480" cy="960120"/>
           </a:xfrm>
           <a:prstGeom prst="rect">
             <a:avLst/>
@@ -4702,42 +5401,97 @@
           <a:noFill/>
         </p:spPr>
         <p:txBody>
-          <a:bodyPr wrap="none">
+          <a:bodyPr wrap="square">
             <a:spAutoFit/>
           </a:bodyPr>
           <a:lstStyle/>
           <a:p>
-            <a:r>
-              <a:rPr sz="3000" b="1">
-                <a:solidFill>
-                  <a:srgbClr val="E6EDF3"/>
-                </a:solidFill>
+            <a:pPr marL="0" indent="0">
+              <a:buNone/>
+            </a:pPr>
+            <a:r>
+              <a:rPr sz="2800" b="1">
+                <a:solidFill>
+                  <a:srgbClr val="202020"/>
+                </a:solidFill>
+                <a:latin typeface="Arial"/>
               </a:rPr>
               <a:t>Demo, deployment and next steps</a:t>
             </a:r>
           </a:p>
           <a:p>
-            <a:r>
-              <a:rPr sz="1400">
-                <a:solidFill>
-                  <a:srgbClr val="2DD4BF"/>
-                </a:solidFill>
-              </a:rPr>
-              <a:t>python server.py → http://127.0.0.1:5000 (no internet needed)</a:t>
-            </a:r>
-          </a:p>
-        </p:txBody>
-      </p:sp>
-      <p:sp>
-        <p:nvSpPr>
-          <p:cNvPr id="3" name="TextBox 2"/>
+            <a:pPr marL="0" indent="0">
+              <a:spcBef>
+                <a:spcPts val="200"/>
+              </a:spcBef>
+              <a:buNone/>
+            </a:pPr>
+            <a:r>
+              <a:rPr sz="1350" b="0">
+                <a:solidFill>
+                  <a:srgbClr val="1F4E9A"/>
+                </a:solidFill>
+                <a:latin typeface="Arial"/>
+              </a:rPr>
+              <a:t>Runs offline on a laptop: run.bat / run.sh → http://127.0.0.1:5000, no internet or cloud needed</a:t>
+            </a:r>
+          </a:p>
+        </p:txBody>
+      </p:sp>
+      <p:sp>
+        <p:nvSpPr>
+          <p:cNvPr id="4" name="Rectangle 3"/>
+          <p:cNvSpPr/>
+          <p:nvPr/>
+        </p:nvSpPr>
+        <p:spPr>
+          <a:xfrm>
+            <a:off x="457200" y="6391656"/>
+            <a:ext cx="11274552" cy="10972"/>
+          </a:xfrm>
+          <a:prstGeom prst="rect">
+            <a:avLst/>
+          </a:prstGeom>
+          <a:solidFill>
+            <a:srgbClr val="C9D3E3"/>
+          </a:solidFill>
+          <a:ln>
+            <a:noFill/>
+          </a:ln>
+          <a:effectLst/>
+        </p:spPr>
+        <p:style>
+          <a:lnRef idx="1">
+            <a:schemeClr val="accent1"/>
+          </a:lnRef>
+          <a:fillRef idx="3">
+            <a:schemeClr val="accent1"/>
+          </a:fillRef>
+          <a:effectRef idx="2">
+            <a:schemeClr val="accent1"/>
+          </a:effectRef>
+          <a:fontRef idx="minor">
+            <a:schemeClr val="lt1"/>
+          </a:fontRef>
+        </p:style>
+        <p:txBody>
+          <a:bodyPr rtlCol="0" anchor="ctr"/>
+          <a:lstStyle/>
+          <a:p>
+            <a:pPr algn="ctr"/>
+          </a:p>
+        </p:txBody>
+      </p:sp>
+      <p:sp>
+        <p:nvSpPr>
+          <p:cNvPr id="5" name="TextBox 4"/>
           <p:cNvSpPr txBox="1"/>
           <p:nvPr/>
         </p:nvSpPr>
         <p:spPr>
           <a:xfrm>
-            <a:off x="548640" y="1600200"/>
-            <a:ext cx="11064240" cy="5029200"/>
+            <a:off x="457200" y="6419088"/>
+            <a:ext cx="9144000" cy="274320"/>
           </a:xfrm>
           <a:prstGeom prst="rect">
             <a:avLst/>
@@ -4750,118 +5504,672 @@
           </a:bodyPr>
           <a:lstStyle/>
           <a:p>
-            <a:pPr>
-              <a:spcAft>
-                <a:spcPts val="800"/>
-              </a:spcAft>
-            </a:pPr>
-            <a:r>
-              <a:rPr b="1" sz="1900">
-                <a:solidFill>
-                  <a:srgbClr val="2DD4BF"/>
-                </a:solidFill>
-              </a:rPr>
-              <a:t>Demo:</a:t>
-            </a:r>
-            <a:r>
-              <a:rPr sz="1900">
-                <a:solidFill>
-                  <a:srgbClr val="E6EDF3"/>
-                </a:solidFill>
-              </a:rPr>
-              <a:t> drop any PS dataset file or PCAP (format auto-detected) or pick one of 8 bundled real captures → timeline, forecast fan, ATT&amp;CK stage mix, IG attributions and flagged hosts &amp; flows all update live as each window is processed.</a:t>
-            </a:r>
-          </a:p>
-          <a:p>
-            <a:pPr>
-              <a:spcAft>
-                <a:spcPts val="800"/>
-              </a:spcAft>
-            </a:pPr>
-            <a:r>
-              <a:rPr b="1" sz="1900">
-                <a:solidFill>
-                  <a:srgbClr val="2DD4BF"/>
-                </a:solidFill>
-              </a:rPr>
-              <a:t>Reproducible:</a:t>
-            </a:r>
-            <a:r>
-              <a:rPr sz="1900">
-                <a:solidFill>
-                  <a:srgbClr val="E6EDF3"/>
-                </a:solidFill>
-              </a:rPr>
-              <a:t> fetch_datasets.sh → prepare_data.py / prepare_all.py → train.py → evaluate.py; seeded YAML config; weights + results in the repo; pytest suite.</a:t>
-            </a:r>
-          </a:p>
-          <a:p>
-            <a:pPr>
-              <a:spcAft>
-                <a:spcPts val="800"/>
-              </a:spcAft>
-            </a:pPr>
-            <a:r>
-              <a:rPr b="1" sz="1900">
-                <a:solidFill>
-                  <a:srgbClr val="2DD4BF"/>
-                </a:solidFill>
-              </a:rPr>
-              <a:t>Enterprise / CII fit:</a:t>
-            </a:r>
-            <a:r>
-              <a:rPr sz="1900">
-                <a:solidFill>
-                  <a:srgbClr val="E6EDF3"/>
-                </a:solidFill>
-              </a:rPr>
-              <a:t> streams captures in bounded memory, CPU or GPU, fully offline, explains every alert, per-site threshold profiles.</a:t>
-            </a:r>
-          </a:p>
-          <a:p>
-            <a:pPr>
-              <a:spcAft>
-                <a:spcPts val="800"/>
-              </a:spcAft>
-            </a:pPr>
-            <a:r>
-              <a:rPr b="1" sz="1900">
-                <a:solidFill>
-                  <a:srgbClr val="2DD4BF"/>
-                </a:solidFill>
-              </a:rPr>
-              <a:t>Limitations:</a:t>
-            </a:r>
-            <a:r>
-              <a:rPr sz="1900">
-                <a:solidFill>
-                  <a:srgbClr val="E6EDF3"/>
-                </a:solidFill>
-              </a:rPr>
-              <a:t> CICIoT2023 episodes are composed; LANL labels come from authentication-based red-team events; alert thresholds need per-site calibration.</a:t>
-            </a:r>
-          </a:p>
-          <a:p>
-            <a:pPr>
-              <a:spcAft>
-                <a:spcPts val="800"/>
-              </a:spcAft>
-            </a:pPr>
-            <a:r>
-              <a:rPr b="1" sz="1900">
-                <a:solidFill>
-                  <a:srgbClr val="2DD4BF"/>
-                </a:solidFill>
-              </a:rPr>
-              <a:t>Next:</a:t>
-            </a:r>
-            <a:r>
-              <a:rPr sz="1900">
-                <a:solidFill>
-                  <a:srgbClr val="E6EDF3"/>
-                </a:solidFill>
-              </a:rPr>
-              <a:t> graph (host-level GNN) state, online threshold calibration, streaming NetFlow/IPFIX collector, SOC integration (syslog/STIX).</a:t>
+            <a:pPr marL="0" indent="0">
+              <a:buNone/>
+            </a:pPr>
+            <a:r>
+              <a:rPr sz="900" b="0">
+                <a:solidFill>
+                  <a:srgbClr val="555555"/>
+                </a:solidFill>
+                <a:latin typeface="Arial"/>
+              </a:rPr>
+              <a:t>VIGHNAX · SIH 2026 · PS SIH26153 (NTRO) · Team ID 127364</a:t>
+            </a:r>
+          </a:p>
+        </p:txBody>
+      </p:sp>
+      <p:sp>
+        <p:nvSpPr>
+          <p:cNvPr id="6" name="TextBox 5"/>
+          <p:cNvSpPr txBox="1"/>
+          <p:nvPr/>
+        </p:nvSpPr>
+        <p:spPr>
+          <a:xfrm>
+            <a:off x="10789920" y="6419088"/>
+            <a:ext cx="941832" cy="274320"/>
+          </a:xfrm>
+          <a:prstGeom prst="rect">
+            <a:avLst/>
+          </a:prstGeom>
+          <a:noFill/>
+        </p:spPr>
+        <p:txBody>
+          <a:bodyPr wrap="square">
+            <a:spAutoFit/>
+          </a:bodyPr>
+          <a:lstStyle/>
+          <a:p>
+            <a:pPr marL="0" indent="0" algn="r">
+              <a:buNone/>
+            </a:pPr>
+            <a:r>
+              <a:rPr sz="900" b="0">
+                <a:solidFill>
+                  <a:srgbClr val="555555"/>
+                </a:solidFill>
+                <a:latin typeface="Arial"/>
+              </a:rPr>
+              <a:t>5 / 5</a:t>
+            </a:r>
+          </a:p>
+        </p:txBody>
+      </p:sp>
+      <p:sp>
+        <p:nvSpPr>
+          <p:cNvPr id="7" name="Rounded Rectangle 6"/>
+          <p:cNvSpPr/>
+          <p:nvPr/>
+        </p:nvSpPr>
+        <p:spPr>
+          <a:xfrm>
+            <a:off x="457200" y="1417320"/>
+            <a:ext cx="3657599" cy="1714500"/>
+          </a:xfrm>
+          <a:prstGeom prst="roundRect">
+            <a:avLst>
+              <a:gd name="adj" fmla="val 7000"/>
+            </a:avLst>
+          </a:prstGeom>
+          <a:solidFill>
+            <a:srgbClr val="EEF3FA"/>
+          </a:solidFill>
+          <a:ln>
+            <a:noFill/>
+          </a:ln>
+          <a:effectLst/>
+        </p:spPr>
+        <p:style>
+          <a:lnRef idx="1">
+            <a:schemeClr val="accent1"/>
+          </a:lnRef>
+          <a:fillRef idx="3">
+            <a:schemeClr val="accent1"/>
+          </a:fillRef>
+          <a:effectRef idx="2">
+            <a:schemeClr val="accent1"/>
+          </a:effectRef>
+          <a:fontRef idx="minor">
+            <a:schemeClr val="lt1"/>
+          </a:fontRef>
+        </p:style>
+        <p:txBody>
+          <a:bodyPr rtlCol="0" anchor="t" wrap="square" lIns="164592" rIns="164592" tIns="128016" bIns="64008"/>
+          <a:lstStyle/>
+          <a:p>
+            <a:pPr algn="l" marL="0" indent="0">
+              <a:buNone/>
+            </a:pPr>
+            <a:r>
+              <a:rPr sz="1500" b="1">
+                <a:solidFill>
+                  <a:srgbClr val="1F4E9A"/>
+                </a:solidFill>
+                <a:latin typeface="Arial"/>
+              </a:rPr>
+              <a:t>Demo</a:t>
+            </a:r>
+          </a:p>
+          <a:p>
+            <a:pPr marL="0" indent="0" algn="l">
+              <a:spcBef>
+                <a:spcPts val="300"/>
+              </a:spcBef>
+              <a:buNone/>
+            </a:pPr>
+            <a:r>
+              <a:rPr sz="1400" b="0">
+                <a:solidFill>
+                  <a:srgbClr val="202020"/>
+                </a:solidFill>
+                <a:latin typeface="Arial"/>
+              </a:rPr>
+              <a:t>Drop a PCAP, flow CSV or .zip, or pick one of 8 bundled real captures. Timeline, forecast, stage mix, explanations and flagged hosts update live, window by window.</a:t>
+            </a:r>
+          </a:p>
+        </p:txBody>
+      </p:sp>
+      <p:sp>
+        <p:nvSpPr>
+          <p:cNvPr id="8" name="Rounded Rectangle 7"/>
+          <p:cNvSpPr/>
+          <p:nvPr/>
+        </p:nvSpPr>
+        <p:spPr>
+          <a:xfrm>
+            <a:off x="4297679" y="1417320"/>
+            <a:ext cx="3657599" cy="1714500"/>
+          </a:xfrm>
+          <a:prstGeom prst="roundRect">
+            <a:avLst>
+              <a:gd name="adj" fmla="val 7000"/>
+            </a:avLst>
+          </a:prstGeom>
+          <a:solidFill>
+            <a:srgbClr val="EEF3FA"/>
+          </a:solidFill>
+          <a:ln>
+            <a:noFill/>
+          </a:ln>
+          <a:effectLst/>
+        </p:spPr>
+        <p:style>
+          <a:lnRef idx="1">
+            <a:schemeClr val="accent1"/>
+          </a:lnRef>
+          <a:fillRef idx="3">
+            <a:schemeClr val="accent1"/>
+          </a:fillRef>
+          <a:effectRef idx="2">
+            <a:schemeClr val="accent1"/>
+          </a:effectRef>
+          <a:fontRef idx="minor">
+            <a:schemeClr val="lt1"/>
+          </a:fontRef>
+        </p:style>
+        <p:txBody>
+          <a:bodyPr rtlCol="0" anchor="t" wrap="square" lIns="164592" rIns="164592" tIns="128016" bIns="64008"/>
+          <a:lstStyle/>
+          <a:p>
+            <a:pPr algn="l" marL="0" indent="0">
+              <a:buNone/>
+            </a:pPr>
+            <a:r>
+              <a:rPr sz="1500" b="1">
+                <a:solidFill>
+                  <a:srgbClr val="1F4E9A"/>
+                </a:solidFill>
+                <a:latin typeface="Arial"/>
+              </a:rPr>
+              <a:t>Deployment fit</a:t>
+            </a:r>
+          </a:p>
+          <a:p>
+            <a:pPr marL="0" indent="0" algn="l">
+              <a:spcBef>
+                <a:spcPts val="300"/>
+              </a:spcBef>
+              <a:buNone/>
+            </a:pPr>
+            <a:r>
+              <a:rPr sz="1400" b="0">
+                <a:solidFill>
+                  <a:srgbClr val="202020"/>
+                </a:solidFill>
+                <a:latin typeface="Arial"/>
+              </a:rPr>
+              <a:t>Air-gapped and CPU-only; streams captures in bounded memory; SHA-256-verified weights; per-site alert thresholds; one-click incident report.</a:t>
+            </a:r>
+          </a:p>
+        </p:txBody>
+      </p:sp>
+      <p:sp>
+        <p:nvSpPr>
+          <p:cNvPr id="9" name="Rounded Rectangle 8"/>
+          <p:cNvSpPr/>
+          <p:nvPr/>
+        </p:nvSpPr>
+        <p:spPr>
+          <a:xfrm>
+            <a:off x="457200" y="3314700"/>
+            <a:ext cx="3657599" cy="1714500"/>
+          </a:xfrm>
+          <a:prstGeom prst="roundRect">
+            <a:avLst>
+              <a:gd name="adj" fmla="val 7000"/>
+            </a:avLst>
+          </a:prstGeom>
+          <a:solidFill>
+            <a:srgbClr val="EEF3FA"/>
+          </a:solidFill>
+          <a:ln>
+            <a:noFill/>
+          </a:ln>
+          <a:effectLst/>
+        </p:spPr>
+        <p:style>
+          <a:lnRef idx="1">
+            <a:schemeClr val="accent1"/>
+          </a:lnRef>
+          <a:fillRef idx="3">
+            <a:schemeClr val="accent1"/>
+          </a:fillRef>
+          <a:effectRef idx="2">
+            <a:schemeClr val="accent1"/>
+          </a:effectRef>
+          <a:fontRef idx="minor">
+            <a:schemeClr val="lt1"/>
+          </a:fontRef>
+        </p:style>
+        <p:txBody>
+          <a:bodyPr rtlCol="0" anchor="t" wrap="square" lIns="164592" rIns="164592" tIns="128016" bIns="64008"/>
+          <a:lstStyle/>
+          <a:p>
+            <a:pPr algn="l" marL="0" indent="0">
+              <a:buNone/>
+            </a:pPr>
+            <a:r>
+              <a:rPr sz="1500" b="1">
+                <a:solidFill>
+                  <a:srgbClr val="1F4E9A"/>
+                </a:solidFill>
+                <a:latin typeface="Arial"/>
+              </a:rPr>
+              <a:t>Limits, stated plainly</a:t>
+            </a:r>
+          </a:p>
+          <a:p>
+            <a:pPr marL="0" indent="0" algn="l">
+              <a:spcBef>
+                <a:spcPts val="300"/>
+              </a:spcBef>
+              <a:buNone/>
+            </a:pPr>
+            <a:r>
+              <a:rPr sz="1400" b="0">
+                <a:solidFill>
+                  <a:srgbClr val="202020"/>
+                </a:solidFill>
+                <a:latin typeface="Arial"/>
+              </a:rPr>
+              <a:t>Weak on LANL-type authentication attacks and behind the baseline on DARPA 1999; CICIoT2023 episodes are composed; thresholds need per-site calibration.</a:t>
+            </a:r>
+          </a:p>
+        </p:txBody>
+      </p:sp>
+      <p:sp>
+        <p:nvSpPr>
+          <p:cNvPr id="10" name="Rounded Rectangle 9"/>
+          <p:cNvSpPr/>
+          <p:nvPr/>
+        </p:nvSpPr>
+        <p:spPr>
+          <a:xfrm>
+            <a:off x="4297679" y="3314700"/>
+            <a:ext cx="3657599" cy="1714500"/>
+          </a:xfrm>
+          <a:prstGeom prst="roundRect">
+            <a:avLst>
+              <a:gd name="adj" fmla="val 7000"/>
+            </a:avLst>
+          </a:prstGeom>
+          <a:solidFill>
+            <a:srgbClr val="EEF3FA"/>
+          </a:solidFill>
+          <a:ln>
+            <a:noFill/>
+          </a:ln>
+          <a:effectLst/>
+        </p:spPr>
+        <p:style>
+          <a:lnRef idx="1">
+            <a:schemeClr val="accent1"/>
+          </a:lnRef>
+          <a:fillRef idx="3">
+            <a:schemeClr val="accent1"/>
+          </a:fillRef>
+          <a:effectRef idx="2">
+            <a:schemeClr val="accent1"/>
+          </a:effectRef>
+          <a:fontRef idx="minor">
+            <a:schemeClr val="lt1"/>
+          </a:fontRef>
+        </p:style>
+        <p:txBody>
+          <a:bodyPr rtlCol="0" anchor="t" wrap="square" lIns="164592" rIns="164592" tIns="128016" bIns="64008"/>
+          <a:lstStyle/>
+          <a:p>
+            <a:pPr algn="l" marL="0" indent="0">
+              <a:buNone/>
+            </a:pPr>
+            <a:r>
+              <a:rPr sz="1500" b="1">
+                <a:solidFill>
+                  <a:srgbClr val="1F4E9A"/>
+                </a:solidFill>
+                <a:latin typeface="Arial"/>
+              </a:rPr>
+              <a:t>Next steps</a:t>
+            </a:r>
+          </a:p>
+          <a:p>
+            <a:pPr marL="0" indent="0" algn="l">
+              <a:spcBef>
+                <a:spcPts val="300"/>
+              </a:spcBef>
+              <a:buNone/>
+            </a:pPr>
+            <a:r>
+              <a:rPr sz="1400" b="0">
+                <a:solidFill>
+                  <a:srgbClr val="202020"/>
+                </a:solidFill>
+                <a:latin typeface="Arial"/>
+              </a:rPr>
+              <a:t>Host-graph (GNN) state, online threshold calibration, a streaming NetFlow / IPFIX collector and SOC integration (syslog, STIX).</a:t>
+            </a:r>
+          </a:p>
+        </p:txBody>
+      </p:sp>
+      <p:sp>
+        <p:nvSpPr>
+          <p:cNvPr id="11" name="Rounded Rectangle 10"/>
+          <p:cNvSpPr/>
+          <p:nvPr/>
+        </p:nvSpPr>
+        <p:spPr>
+          <a:xfrm>
+            <a:off x="457200" y="5212080"/>
+            <a:ext cx="7498079" cy="1005840"/>
+          </a:xfrm>
+          <a:prstGeom prst="roundRect">
+            <a:avLst>
+              <a:gd name="adj" fmla="val 7000"/>
+            </a:avLst>
+          </a:prstGeom>
+          <a:solidFill>
+            <a:srgbClr val="EEF3FA"/>
+          </a:solidFill>
+          <a:ln>
+            <a:noFill/>
+          </a:ln>
+          <a:effectLst/>
+        </p:spPr>
+        <p:style>
+          <a:lnRef idx="1">
+            <a:schemeClr val="accent1"/>
+          </a:lnRef>
+          <a:fillRef idx="3">
+            <a:schemeClr val="accent1"/>
+          </a:fillRef>
+          <a:effectRef idx="2">
+            <a:schemeClr val="accent1"/>
+          </a:effectRef>
+          <a:fontRef idx="minor">
+            <a:schemeClr val="lt1"/>
+          </a:fontRef>
+        </p:style>
+        <p:txBody>
+          <a:bodyPr rtlCol="0" anchor="t" wrap="square" lIns="164592" rIns="164592" tIns="128016" bIns="64008"/>
+          <a:lstStyle/>
+          <a:p>
+            <a:pPr algn="l" marL="0" indent="0">
+              <a:buNone/>
+            </a:pPr>
+            <a:r>
+              <a:rPr sz="1400" b="1">
+                <a:solidFill>
+                  <a:srgbClr val="1F4E9A"/>
+                </a:solidFill>
+                <a:latin typeface="Arial"/>
+              </a:rPr>
+              <a:t>Reproduce every number</a:t>
+            </a:r>
+          </a:p>
+          <a:p>
+            <a:pPr marL="0" indent="0" algn="l">
+              <a:spcBef>
+                <a:spcPts val="300"/>
+              </a:spcBef>
+              <a:buNone/>
+            </a:pPr>
+            <a:r>
+              <a:rPr sz="1300" b="0">
+                <a:solidFill>
+                  <a:srgbClr val="202020"/>
+                </a:solidFill>
+                <a:latin typeface="Arial"/>
+              </a:rPr>
+              <a:t>fetch_datasets.sh → prepare_data.py / prepare_all.py → train.py → evaluate.py · one seeded config (configs/default.yaml, seed 42) · pytest suite</a:t>
+            </a:r>
+          </a:p>
+        </p:txBody>
+      </p:sp>
+      <p:sp>
+        <p:nvSpPr>
+          <p:cNvPr id="12" name="Rounded Rectangle 11"/>
+          <p:cNvSpPr/>
+          <p:nvPr/>
+        </p:nvSpPr>
+        <p:spPr>
+          <a:xfrm>
+            <a:off x="8229600" y="1417320"/>
+            <a:ext cx="3502152" cy="2313432"/>
+          </a:xfrm>
+          <a:prstGeom prst="roundRect">
+            <a:avLst>
+              <a:gd name="adj" fmla="val 7000"/>
+            </a:avLst>
+          </a:prstGeom>
+          <a:solidFill>
+            <a:srgbClr val="EEF3FA"/>
+          </a:solidFill>
+          <a:ln>
+            <a:noFill/>
+          </a:ln>
+          <a:effectLst/>
+        </p:spPr>
+        <p:style>
+          <a:lnRef idx="1">
+            <a:schemeClr val="accent1"/>
+          </a:lnRef>
+          <a:fillRef idx="3">
+            <a:schemeClr val="accent1"/>
+          </a:fillRef>
+          <a:effectRef idx="2">
+            <a:schemeClr val="accent1"/>
+          </a:effectRef>
+          <a:fontRef idx="minor">
+            <a:schemeClr val="lt1"/>
+          </a:fontRef>
+        </p:style>
+        <p:txBody>
+          <a:bodyPr rtlCol="0" anchor="ctr" wrap="square" lIns="128016" rIns="128016" tIns="64008" bIns="64008"/>
+          <a:lstStyle/>
+          <a:p>
+            <a:pPr algn="ctr"/>
+          </a:p>
+        </p:txBody>
+      </p:sp>
+      <p:pic>
+        <p:nvPicPr>
+          <p:cNvPr id="13" name="Picture 12" descr="qr_demo.png">
+            <a:hlinkClick r:id="rId4"/>
+          </p:cNvPr>
+          <p:cNvPicPr>
+            <a:picLocks noChangeAspect="1"/>
+          </p:cNvPicPr>
+          <p:nvPr/>
+        </p:nvPicPr>
+        <p:blipFill>
+          <a:blip r:embed="rId3"/>
+          <a:stretch>
+            <a:fillRect/>
+          </a:stretch>
+        </p:blipFill>
+        <p:spPr>
+          <a:xfrm>
+            <a:off x="9226296" y="1545336"/>
+            <a:ext cx="1508760" cy="1508760"/>
+          </a:xfrm>
+          <a:prstGeom prst="rect">
+            <a:avLst/>
+          </a:prstGeom>
+        </p:spPr>
+      </p:pic>
+      <p:sp>
+        <p:nvSpPr>
+          <p:cNvPr id="14" name="TextBox 13"/>
+          <p:cNvSpPr txBox="1"/>
+          <p:nvPr/>
+        </p:nvSpPr>
+        <p:spPr>
+          <a:xfrm>
+            <a:off x="8229600" y="3090672"/>
+            <a:ext cx="3502152" cy="594360"/>
+          </a:xfrm>
+          <a:prstGeom prst="rect">
+            <a:avLst/>
+          </a:prstGeom>
+          <a:noFill/>
+        </p:spPr>
+        <p:txBody>
+          <a:bodyPr wrap="square">
+            <a:spAutoFit/>
+          </a:bodyPr>
+          <a:lstStyle/>
+          <a:p>
+            <a:pPr marL="0" indent="0" algn="ctr">
+              <a:buNone/>
+            </a:pPr>
+            <a:r>
+              <a:rPr sz="1400" b="1">
+                <a:solidFill>
+                  <a:srgbClr val="1F4E9A"/>
+                </a:solidFill>
+                <a:latin typeface="Arial"/>
+                <a:hlinkClick r:id="rId4"/>
+              </a:rPr>
+              <a:t>Demo video</a:t>
+            </a:r>
+          </a:p>
+          <a:p>
+            <a:pPr marL="0" indent="0" algn="ctr">
+              <a:buNone/>
+            </a:pPr>
+            <a:r>
+              <a:rPr sz="1050" b="0">
+                <a:solidFill>
+                  <a:srgbClr val="555555"/>
+                </a:solidFill>
+                <a:latin typeface="Arial"/>
+              </a:rPr>
+              <a:t>YouTube · 2 minutes</a:t>
+            </a:r>
+          </a:p>
+        </p:txBody>
+      </p:sp>
+      <p:sp>
+        <p:nvSpPr>
+          <p:cNvPr id="15" name="Rounded Rectangle 14"/>
+          <p:cNvSpPr/>
+          <p:nvPr/>
+        </p:nvSpPr>
+        <p:spPr>
+          <a:xfrm>
+            <a:off x="8229600" y="3904488"/>
+            <a:ext cx="3502152" cy="2313432"/>
+          </a:xfrm>
+          <a:prstGeom prst="roundRect">
+            <a:avLst>
+              <a:gd name="adj" fmla="val 7000"/>
+            </a:avLst>
+          </a:prstGeom>
+          <a:solidFill>
+            <a:srgbClr val="EEF3FA"/>
+          </a:solidFill>
+          <a:ln>
+            <a:noFill/>
+          </a:ln>
+          <a:effectLst/>
+        </p:spPr>
+        <p:style>
+          <a:lnRef idx="1">
+            <a:schemeClr val="accent1"/>
+          </a:lnRef>
+          <a:fillRef idx="3">
+            <a:schemeClr val="accent1"/>
+          </a:fillRef>
+          <a:effectRef idx="2">
+            <a:schemeClr val="accent1"/>
+          </a:effectRef>
+          <a:fontRef idx="minor">
+            <a:schemeClr val="lt1"/>
+          </a:fontRef>
+        </p:style>
+        <p:txBody>
+          <a:bodyPr rtlCol="0" anchor="ctr" wrap="square" lIns="128016" rIns="128016" tIns="64008" bIns="64008"/>
+          <a:lstStyle/>
+          <a:p>
+            <a:pPr algn="ctr"/>
+          </a:p>
+        </p:txBody>
+      </p:sp>
+      <p:pic>
+        <p:nvPicPr>
+          <p:cNvPr id="16" name="Picture 15" descr="qr_source.png">
+            <a:hlinkClick r:id="rId6"/>
+          </p:cNvPr>
+          <p:cNvPicPr>
+            <a:picLocks noChangeAspect="1"/>
+          </p:cNvPicPr>
+          <p:nvPr/>
+        </p:nvPicPr>
+        <p:blipFill>
+          <a:blip r:embed="rId5"/>
+          <a:stretch>
+            <a:fillRect/>
+          </a:stretch>
+        </p:blipFill>
+        <p:spPr>
+          <a:xfrm>
+            <a:off x="9226296" y="4032504"/>
+            <a:ext cx="1508760" cy="1508760"/>
+          </a:xfrm>
+          <a:prstGeom prst="rect">
+            <a:avLst/>
+          </a:prstGeom>
+        </p:spPr>
+      </p:pic>
+      <p:sp>
+        <p:nvSpPr>
+          <p:cNvPr id="17" name="TextBox 16"/>
+          <p:cNvSpPr txBox="1"/>
+          <p:nvPr/>
+        </p:nvSpPr>
+        <p:spPr>
+          <a:xfrm>
+            <a:off x="8229600" y="5577840"/>
+            <a:ext cx="3502152" cy="594360"/>
+          </a:xfrm>
+          <a:prstGeom prst="rect">
+            <a:avLst/>
+          </a:prstGeom>
+          <a:noFill/>
+        </p:spPr>
+        <p:txBody>
+          <a:bodyPr wrap="square">
+            <a:spAutoFit/>
+          </a:bodyPr>
+          <a:lstStyle/>
+          <a:p>
+            <a:pPr marL="0" indent="0" algn="ctr">
+              <a:buNone/>
+            </a:pPr>
+            <a:r>
+              <a:rPr sz="1400" b="1">
+                <a:solidFill>
+                  <a:srgbClr val="1F4E9A"/>
+                </a:solidFill>
+                <a:latin typeface="Arial"/>
+                <a:hlinkClick r:id="rId6"/>
+              </a:rPr>
+              <a:t>Source code</a:t>
+            </a:r>
+          </a:p>
+          <a:p>
+            <a:pPr marL="0" indent="0" algn="ctr">
+              <a:buNone/>
+            </a:pPr>
+            <a:r>
+              <a:rPr sz="1050" b="0">
+                <a:solidFill>
+                  <a:srgbClr val="555555"/>
+                </a:solidFill>
+                <a:latin typeface="Arial"/>
+              </a:rPr>
+              <a:t>GitHub · weights · benchmark</a:t>
             </a:r>
           </a:p>
         </p:txBody>

</xml_diff>